<commit_message>
Clase 4: explicar JUnit desde cero en guía, presentación y README
La clase 1 ya no usa JUnit y las clases 2 y 3 usan Cucumber, así que en
la clase 4 se presenta JUnit por primera vez: @Test, @DisplayName y
assertEquals(esperado, real) antes de usarlos.

Co-Authored-By: Claude Opus 5 (1M context) <noreply@anthropic.com>
Claude-Session: https://claude.ai/code/session_01L2JuF1iG72koPJkmuRWSzm
</commit_message>
<xml_diff>
--- a/material-de-apoyo/Clase4_Presentacion_Playwright_POM.pptx
+++ b/material-de-apoyo/Clase4_Presentacion_Playwright_POM.pptx
@@ -7112,11 +7112,20 @@
             <a:r>
               <a:rPr b="0" sz="1600">
                 <a:solidFill>
+                  <a:srgbClr val="36B5FF"/>
+                </a:solidFill>
+                <a:latin typeface="Consolas"/>
+              </a:rPr>
+              <a:t>@Test</a:t>
+            </a:r>
+            <a:r>
+              <a:rPr b="0" sz="1600">
+                <a:solidFill>
                   <a:srgbClr val="FFFFFF"/>
                 </a:solidFill>
                 <a:latin typeface="Century Gothic"/>
               </a:rPr>
-              <a:t>Crear la página</a:t>
+              <a:t> marca el método como prueba de JUnit</a:t>
             </a:r>
           </a:p>
           <a:p>
@@ -7137,11 +7146,20 @@
             <a:r>
               <a:rPr b="0" sz="1600">
                 <a:solidFill>
+                  <a:srgbClr val="36B5FF"/>
+                </a:solidFill>
+                <a:latin typeface="Consolas"/>
+              </a:rPr>
+              <a:t>@DisplayName</a:t>
+            </a:r>
+            <a:r>
+              <a:rPr b="0" sz="1600">
+                <a:solidFill>
                   <a:srgbClr val="FFFFFF"/>
                 </a:solidFill>
                 <a:latin typeface="Century Gothic"/>
               </a:rPr>
-              <a:t>Apretar sus botones</a:t>
+              <a:t>: el nombre que ves en consola</a:t>
             </a:r>
           </a:p>
           <a:p>
@@ -7166,16 +7184,7 @@
                 </a:solidFill>
                 <a:latin typeface="Century Gothic"/>
               </a:rPr>
-              <a:t>Comparar con </a:t>
-            </a:r>
-            <a:r>
-              <a:rPr b="0" sz="1600">
-                <a:solidFill>
-                  <a:srgbClr val="36B5FF"/>
-                </a:solidFill>
-                <a:latin typeface="Consolas"/>
-              </a:rPr>
-              <a:t>assertEquals</a:t>
+              <a:t>Crear la página y apretar sus botones</a:t>
             </a:r>
           </a:p>
           <a:p>
@@ -7196,11 +7205,20 @@
             <a:r>
               <a:rPr b="0" sz="1600">
                 <a:solidFill>
+                  <a:srgbClr val="36B5FF"/>
+                </a:solidFill>
+                <a:latin typeface="Consolas"/>
+              </a:rPr>
+              <a:t>assertEquals(esperado, real)</a:t>
+            </a:r>
+            <a:r>
+              <a:rPr b="0" sz="1600">
+                <a:solidFill>
                   <a:srgbClr val="FFFFFF"/>
                 </a:solidFill>
                 <a:latin typeface="Century Gothic"/>
               </a:rPr>
-              <a:t>Ni un localizador en la prueba</a:t>
+              <a:t>: si no son iguales, la prueba falla</a:t>
             </a:r>
           </a:p>
         </p:txBody>

</xml_diff>

<commit_message>
Clase 4: rehacer con Playwright en TypeScript, POM y VS Code
Se reemplaza el proyecto Java/Gradle por Playwright Test 1.63.0 con
TypeScript: LoginPage y ProductosPage, datos en data/usuarios.ts,
login.spec.ts con dos pruebas y casos inválidos con un for, reporte
HTML, captura y traza en fallo, y recomendación de la extensión de
Playwright para VS Code. Nuevos README, guía de estudio, presentación
y actividad.

Co-Authored-By: Claude Opus 5 (1M context) <noreply@anthropic.com>
Claude-Session: https://claude.ai/code/session_01L2JuF1iG72koPJkmuRWSzm
</commit_message>
<xml_diff>
--- a/material-de-apoyo/Clase4_Presentacion_Playwright_POM.pptx
+++ b/material-de-apoyo/Clase4_Presentacion_Playwright_POM.pptx
@@ -3267,7 +3267,7 @@
                 </a:solidFill>
                 <a:latin typeface="Century Gothic"/>
               </a:rPr>
-              <a:t>Los mismos logins de la clase 2, con otra herramienta y otro patrón</a:t>
+              <a:t>Los mismos logins de la clase 2, ahora en TypeScript y VS Code</a:t>
             </a:r>
           </a:p>
         </p:txBody>
@@ -3465,7 +3465,7 @@
                 </a:solidFill>
                 <a:latin typeface="Consolas"/>
               </a:rPr>
-              <a:t>gradle instalarNavegadores</a:t>
+              <a:t>npm ci</a:t>
             </a:r>
             <a:r>
               <a:rPr b="0" sz="1800">
@@ -3474,7 +3474,25 @@
                 </a:solidFill>
                 <a:latin typeface="Century Gothic"/>
               </a:rPr>
-              <a:t> una vez por equipo</a:t>
+              <a:t> y </a:t>
+            </a:r>
+            <a:r>
+              <a:rPr b="0" sz="1800">
+                <a:solidFill>
+                  <a:srgbClr val="36B5FF"/>
+                </a:solidFill>
+                <a:latin typeface="Consolas"/>
+              </a:rPr>
+              <a:t>npm run instalar:navegador</a:t>
+            </a:r>
+            <a:r>
+              <a:rPr b="0" sz="1800">
+                <a:solidFill>
+                  <a:srgbClr val="FFFFFF"/>
+                </a:solidFill>
+                <a:latin typeface="Century Gothic"/>
+              </a:rPr>
+              <a:t> una vez</a:t>
             </a:r>
           </a:p>
           <a:p>
@@ -3499,7 +3517,7 @@
                 </a:solidFill>
                 <a:latin typeface="Consolas"/>
               </a:rPr>
-              <a:t>gradle test</a:t>
+              <a:t>npm test</a:t>
             </a:r>
             <a:r>
               <a:rPr b="0" sz="1800">
@@ -3508,7 +3526,25 @@
                 </a:solidFill>
                 <a:latin typeface="Century Gothic"/>
               </a:rPr>
-              <a:t> para correr todo</a:t>
+              <a:t> para correr, </a:t>
+            </a:r>
+            <a:r>
+              <a:rPr b="0" sz="1800">
+                <a:solidFill>
+                  <a:srgbClr val="36B5FF"/>
+                </a:solidFill>
+                <a:latin typeface="Consolas"/>
+              </a:rPr>
+              <a:t>npm run reporte</a:t>
+            </a:r>
+            <a:r>
+              <a:rPr b="0" sz="1800">
+                <a:solidFill>
+                  <a:srgbClr val="FFFFFF"/>
+                </a:solidFill>
+                <a:latin typeface="Century Gothic"/>
+              </a:rPr>
+              <a:t> para ver</a:t>
             </a:r>
           </a:p>
           <a:p>
@@ -3533,7 +3569,7 @@
                 </a:solidFill>
                 <a:latin typeface="Consolas"/>
               </a:rPr>
-              <a:t>gradle test -Dheadless=false</a:t>
+              <a:t>await</a:t>
             </a:r>
             <a:r>
               <a:rPr b="0" sz="1800">
@@ -3542,7 +3578,7 @@
                 </a:solidFill>
                 <a:latin typeface="Century Gothic"/>
               </a:rPr>
-              <a:t> para ver el navegador</a:t>
+              <a:t> delante de cada acción y cada expect</a:t>
             </a:r>
           </a:p>
           <a:p>
@@ -3567,7 +3603,7 @@
                 </a:solidFill>
                 <a:latin typeface="Century Gothic"/>
               </a:rPr>
-              <a:t>Localizadores privados, métodos con nombres de lo que hace una persona</a:t>
+              <a:t>Una página por pantalla: cables privados, botones con nombre</a:t>
             </a:r>
           </a:p>
         </p:txBody>
@@ -3682,7 +3718,7 @@
                 </a:solidFill>
                 <a:latin typeface="Century Gothic"/>
               </a:rPr>
-              <a:t>Agregar un producto al carrito y validar que el contador diga 1.</a:t>
+              <a:t>Agregar la mochila al carrito y revisar que el contador diga 1.</a:t>
             </a:r>
           </a:p>
           <a:p>
@@ -3807,7 +3843,7 @@
         <p:spPr>
           <a:xfrm>
             <a:off x="548640" y="411480"/>
-            <a:ext cx="1124712" cy="329184"/>
+            <a:ext cx="1481328" cy="329184"/>
           </a:xfrm>
           <a:prstGeom prst="roundRect">
             <a:avLst>
@@ -3847,7 +3883,7 @@
                 </a:solidFill>
                 <a:latin typeface="Century Gothic"/>
               </a:rPr>
-              <a:t>AGENDA</a:t>
+              <a:t>FRAMEWORK</a:t>
             </a:r>
           </a:p>
         </p:txBody>
@@ -3882,7 +3918,7 @@
                 </a:solidFill>
                 <a:latin typeface="Century Gothic"/>
               </a:rPr>
-              <a:t>Lo que vamos a hacer hoy</a:t>
+              <a:t>Playwright en tres ideas</a:t>
             </a:r>
           </a:p>
         </p:txBody>
@@ -3962,7 +3998,7 @@
                 </a:solidFill>
                 <a:latin typeface="Century Gothic"/>
               </a:rPr>
-              <a:t>Playwright</a:t>
+              <a:t>Maneja el navegador</a:t>
             </a:r>
           </a:p>
         </p:txBody>
@@ -3997,7 +4033,7 @@
                 </a:solidFill>
                 <a:latin typeface="Century Gothic"/>
               </a:rPr>
-              <a:t>Conocer otro framework: cómo encuentra elementos y por qué no necesita esperas a mano.</a:t>
+              <a:t>Abre Chromium, escribe, hace clic y revisa textos desde TypeScript.</a:t>
             </a:r>
           </a:p>
         </p:txBody>
@@ -4077,7 +4113,7 @@
                 </a:solidFill>
                 <a:latin typeface="Century Gothic"/>
               </a:rPr>
-              <a:t>POM</a:t>
+              <a:t>Espera solo</a:t>
             </a:r>
           </a:p>
         </p:txBody>
@@ -4112,7 +4148,7 @@
                 </a:solidFill>
                 <a:latin typeface="Century Gothic"/>
               </a:rPr>
-              <a:t>Ordenar el código con una clase por pantalla: un control remoto para cada una.</a:t>
+              <a:t>Antes de cada acción espera el elemento. Cada expect vuelve a mirar hasta 5 segundos.</a:t>
             </a:r>
           </a:p>
         </p:txBody>
@@ -4192,7 +4228,7 @@
                 </a:solidFill>
                 <a:latin typeface="Century Gothic"/>
               </a:rPr>
-              <a:t>Comparar</a:t>
+              <a:t>Te muestra qué pasó</a:t>
             </a:r>
           </a:p>
         </p:txBody>
@@ -4227,7 +4263,7 @@
                 </a:solidFill>
                 <a:latin typeface="Century Gothic"/>
               </a:rPr>
-              <a:t>Poner POM al lado de Screenplay y decidir cuándo conviene cada uno.</a:t>
+              <a:t>Reporte HTML, captura y traza paso a paso cuando una prueba falla.</a:t>
             </a:r>
           </a:p>
         </p:txBody>
@@ -4337,7 +4373,7 @@
         <p:spPr>
           <a:xfrm>
             <a:off x="548640" y="411480"/>
-            <a:ext cx="1481328" cy="329184"/>
+            <a:ext cx="1362456" cy="329184"/>
           </a:xfrm>
           <a:prstGeom prst="roundRect">
             <a:avLst>
@@ -4377,7 +4413,7 @@
                 </a:solidFill>
                 <a:latin typeface="Century Gothic"/>
               </a:rPr>
-              <a:t>FRAMEWORK</a:t>
+              <a:t>LENGUAJE</a:t>
             </a:r>
           </a:p>
         </p:txBody>
@@ -4412,56 +4448,359 @@
                 </a:solidFill>
                 <a:latin typeface="Century Gothic"/>
               </a:rPr>
-              <a:t>Playwright en tres ideas</a:t>
-            </a:r>
-          </a:p>
-        </p:txBody>
-      </p:sp>
-      <p:sp>
-        <p:nvSpPr>
-          <p:cNvPr id="4" name="Rounded Rectangle 3"/>
-          <p:cNvSpPr/>
-          <p:nvPr/>
-        </p:nvSpPr>
-        <p:spPr>
-          <a:xfrm>
-            <a:off x="548640" y="1737360"/>
-            <a:ext cx="3545738" cy="4389120"/>
-          </a:xfrm>
-          <a:prstGeom prst="roundRect">
-            <a:avLst>
-              <a:gd name="adj" fmla="val 6000"/>
-            </a:avLst>
-          </a:prstGeom>
-          <a:solidFill>
-            <a:srgbClr val="0B2C59"/>
-          </a:solidFill>
-          <a:ln w="15875">
-            <a:solidFill>
-              <a:srgbClr val="5EA7D8"/>
-            </a:solidFill>
-          </a:ln>
-        </p:spPr>
-        <p:style>
-          <a:lnRef idx="1">
-            <a:schemeClr val="accent1"/>
-          </a:lnRef>
-          <a:fillRef idx="3">
-            <a:schemeClr val="accent1"/>
-          </a:fillRef>
-          <a:effectRef idx="2">
-            <a:schemeClr val="accent1"/>
-          </a:effectRef>
-          <a:fontRef idx="minor">
-            <a:schemeClr val="lt1"/>
-          </a:fontRef>
-        </p:style>
-        <p:txBody>
-          <a:bodyPr rtlCol="0" anchor="ctr"/>
-          <a:lstStyle/>
-          <a:p/>
-        </p:txBody>
-      </p:sp>
+              <a:t>De Java a TypeScript</a:t>
+            </a:r>
+          </a:p>
+        </p:txBody>
+      </p:sp>
+      <p:graphicFrame>
+        <p:nvGraphicFramePr>
+          <p:cNvPr id="4" name="Table 3"/>
+          <p:cNvGraphicFramePr>
+            <a:graphicFrameLocks noGrp="1"/>
+          </p:cNvGraphicFramePr>
+          <p:nvPr/>
+        </p:nvGraphicFramePr>
+        <p:xfrm>
+          <a:off x="548640" y="1737360"/>
+          <a:ext cx="11094414" cy="3520440"/>
+        </p:xfrm>
+        <a:graphic>
+          <a:graphicData uri="http://schemas.openxmlformats.org/drawingml/2006/table">
+            <a:tbl>
+              <a:tblPr firstRow="1" bandRow="1">
+                <a:tableStyleId>{5C22544A-7EE6-4342-B048-85BDC9FD1C3A}</a:tableStyleId>
+              </a:tblPr>
+              <a:tblGrid>
+                <a:gridCol w="5042915"/>
+                <a:gridCol w="6051499"/>
+              </a:tblGrid>
+              <a:tr h="502920">
+                <a:tc>
+                  <a:txBody>
+                    <a:bodyPr/>
+                    <a:lstStyle/>
+                    <a:p>
+                      <a:r>
+                        <a:rPr b="1" sz="1400">
+                          <a:solidFill>
+                            <a:srgbClr val="FFFFFF"/>
+                          </a:solidFill>
+                          <a:latin typeface="Century Gothic"/>
+                        </a:rPr>
+                        <a:t>En Java</a:t>
+                      </a:r>
+                    </a:p>
+                  </a:txBody>
+                  <a:tcPr>
+                    <a:solidFill>
+                      <a:srgbClr val="0072BC"/>
+                    </a:solidFill>
+                  </a:tcPr>
+                </a:tc>
+                <a:tc>
+                  <a:txBody>
+                    <a:bodyPr/>
+                    <a:lstStyle/>
+                    <a:p>
+                      <a:r>
+                        <a:rPr b="1" sz="1400">
+                          <a:solidFill>
+                            <a:srgbClr val="FFFFFF"/>
+                          </a:solidFill>
+                          <a:latin typeface="Century Gothic"/>
+                        </a:rPr>
+                        <a:t>En TypeScript</a:t>
+                      </a:r>
+                    </a:p>
+                  </a:txBody>
+                  <a:tcPr>
+                    <a:solidFill>
+                      <a:srgbClr val="0072BC"/>
+                    </a:solidFill>
+                  </a:tcPr>
+                </a:tc>
+              </a:tr>
+              <a:tr h="502920">
+                <a:tc>
+                  <a:txBody>
+                    <a:bodyPr wrap="square"/>
+                    <a:lstStyle/>
+                    <a:p>
+                      <a:r>
+                        <a:rPr b="1" sz="1400">
+                          <a:solidFill>
+                            <a:srgbClr val="FFFFFF"/>
+                          </a:solidFill>
+                          <a:latin typeface="Century Gothic"/>
+                        </a:rPr>
+                        <a:t>String nombre = "Ana";</a:t>
+                      </a:r>
+                    </a:p>
+                  </a:txBody>
+                  <a:tcPr>
+                    <a:solidFill>
+                      <a:srgbClr val="0B2C59"/>
+                    </a:solidFill>
+                  </a:tcPr>
+                </a:tc>
+                <a:tc>
+                  <a:txBody>
+                    <a:bodyPr wrap="square"/>
+                    <a:lstStyle/>
+                    <a:p>
+                      <a:r>
+                        <a:rPr b="0" sz="1400">
+                          <a:solidFill>
+                            <a:srgbClr val="FFFFFF"/>
+                          </a:solidFill>
+                          <a:latin typeface="Century Gothic"/>
+                        </a:rPr>
+                        <a:t>const nombre: string = 'Ana';</a:t>
+                      </a:r>
+                    </a:p>
+                  </a:txBody>
+                  <a:tcPr>
+                    <a:solidFill>
+                      <a:srgbClr val="0B2C59"/>
+                    </a:solidFill>
+                  </a:tcPr>
+                </a:tc>
+              </a:tr>
+              <a:tr h="502920">
+                <a:tc>
+                  <a:txBody>
+                    <a:bodyPr wrap="square"/>
+                    <a:lstStyle/>
+                    <a:p>
+                      <a:r>
+                        <a:rPr b="1" sz="1400">
+                          <a:solidFill>
+                            <a:srgbClr val="FFFFFF"/>
+                          </a:solidFill>
+                          <a:latin typeface="Century Gothic"/>
+                        </a:rPr>
+                        <a:t>private final Locator boton;</a:t>
+                      </a:r>
+                    </a:p>
+                  </a:txBody>
+                  <a:tcPr>
+                    <a:solidFill>
+                      <a:srgbClr val="08264F"/>
+                    </a:solidFill>
+                  </a:tcPr>
+                </a:tc>
+                <a:tc>
+                  <a:txBody>
+                    <a:bodyPr wrap="square"/>
+                    <a:lstStyle/>
+                    <a:p>
+                      <a:r>
+                        <a:rPr b="0" sz="1400">
+                          <a:solidFill>
+                            <a:srgbClr val="FFFFFF"/>
+                          </a:solidFill>
+                          <a:latin typeface="Century Gothic"/>
+                        </a:rPr>
+                        <a:t>private readonly boton: Locator;</a:t>
+                      </a:r>
+                    </a:p>
+                  </a:txBody>
+                  <a:tcPr>
+                    <a:solidFill>
+                      <a:srgbClr val="08264F"/>
+                    </a:solidFill>
+                  </a:tcPr>
+                </a:tc>
+              </a:tr>
+              <a:tr h="502920">
+                <a:tc>
+                  <a:txBody>
+                    <a:bodyPr wrap="square"/>
+                    <a:lstStyle/>
+                    <a:p>
+                      <a:r>
+                        <a:rPr b="1" sz="1400">
+                          <a:solidFill>
+                            <a:srgbClr val="FFFFFF"/>
+                          </a:solidFill>
+                          <a:latin typeface="Century Gothic"/>
+                        </a:rPr>
+                        <a:t>public LoginPage(Page page) { ... }</a:t>
+                      </a:r>
+                    </a:p>
+                  </a:txBody>
+                  <a:tcPr>
+                    <a:solidFill>
+                      <a:srgbClr val="0B2C59"/>
+                    </a:solidFill>
+                  </a:tcPr>
+                </a:tc>
+                <a:tc>
+                  <a:txBody>
+                    <a:bodyPr wrap="square"/>
+                    <a:lstStyle/>
+                    <a:p>
+                      <a:r>
+                        <a:rPr b="0" sz="1400">
+                          <a:solidFill>
+                            <a:srgbClr val="FFFFFF"/>
+                          </a:solidFill>
+                          <a:latin typeface="Century Gothic"/>
+                        </a:rPr>
+                        <a:t>constructor(page: Page) { ... }</a:t>
+                      </a:r>
+                    </a:p>
+                  </a:txBody>
+                  <a:tcPr>
+                    <a:solidFill>
+                      <a:srgbClr val="0B2C59"/>
+                    </a:solidFill>
+                  </a:tcPr>
+                </a:tc>
+              </a:tr>
+              <a:tr h="502920">
+                <a:tc>
+                  <a:txBody>
+                    <a:bodyPr wrap="square"/>
+                    <a:lstStyle/>
+                    <a:p>
+                      <a:r>
+                        <a:rPr b="1" sz="1400">
+                          <a:solidFill>
+                            <a:srgbClr val="FFFFFF"/>
+                          </a:solidFill>
+                          <a:latin typeface="Century Gothic"/>
+                        </a:rPr>
+                        <a:t>import co.com.semillero.pages.LoginPage;</a:t>
+                      </a:r>
+                    </a:p>
+                  </a:txBody>
+                  <a:tcPr>
+                    <a:solidFill>
+                      <a:srgbClr val="08264F"/>
+                    </a:solidFill>
+                  </a:tcPr>
+                </a:tc>
+                <a:tc>
+                  <a:txBody>
+                    <a:bodyPr wrap="square"/>
+                    <a:lstStyle/>
+                    <a:p>
+                      <a:r>
+                        <a:rPr b="0" sz="1400">
+                          <a:solidFill>
+                            <a:srgbClr val="FFFFFF"/>
+                          </a:solidFill>
+                          <a:latin typeface="Century Gothic"/>
+                        </a:rPr>
+                        <a:t>import { LoginPage } from '../pages/LoginPage';</a:t>
+                      </a:r>
+                    </a:p>
+                  </a:txBody>
+                  <a:tcPr>
+                    <a:solidFill>
+                      <a:srgbClr val="08264F"/>
+                    </a:solidFill>
+                  </a:tcPr>
+                </a:tc>
+              </a:tr>
+              <a:tr h="502920">
+                <a:tc>
+                  <a:txBody>
+                    <a:bodyPr wrap="square"/>
+                    <a:lstStyle/>
+                    <a:p>
+                      <a:r>
+                        <a:rPr b="1" sz="1400">
+                          <a:solidFill>
+                            <a:srgbClr val="FFFFFF"/>
+                          </a:solidFill>
+                          <a:latin typeface="Century Gothic"/>
+                        </a:rPr>
+                        <a:t>public class se usa desde otra clase</a:t>
+                      </a:r>
+                    </a:p>
+                  </a:txBody>
+                  <a:tcPr>
+                    <a:solidFill>
+                      <a:srgbClr val="0B2C59"/>
+                    </a:solidFill>
+                  </a:tcPr>
+                </a:tc>
+                <a:tc>
+                  <a:txBody>
+                    <a:bodyPr wrap="square"/>
+                    <a:lstStyle/>
+                    <a:p>
+                      <a:r>
+                        <a:rPr b="0" sz="1400">
+                          <a:solidFill>
+                            <a:srgbClr val="FFFFFF"/>
+                          </a:solidFill>
+                          <a:latin typeface="Century Gothic"/>
+                        </a:rPr>
+                        <a:t>export class se puede importar desde otro archivo</a:t>
+                      </a:r>
+                    </a:p>
+                  </a:txBody>
+                  <a:tcPr>
+                    <a:solidFill>
+                      <a:srgbClr val="0B2C59"/>
+                    </a:solidFill>
+                  </a:tcPr>
+                </a:tc>
+              </a:tr>
+              <a:tr h="502920">
+                <a:tc>
+                  <a:txBody>
+                    <a:bodyPr wrap="square"/>
+                    <a:lstStyle/>
+                    <a:p>
+                      <a:r>
+                        <a:rPr b="1" sz="1400">
+                          <a:solidFill>
+                            <a:srgbClr val="FFFFFF"/>
+                          </a:solidFill>
+                          <a:latin typeface="Century Gothic"/>
+                        </a:rPr>
+                        <a:t>@Test void loginExitoso() { ... }</a:t>
+                      </a:r>
+                    </a:p>
+                  </a:txBody>
+                  <a:tcPr>
+                    <a:solidFill>
+                      <a:srgbClr val="08264F"/>
+                    </a:solidFill>
+                  </a:tcPr>
+                </a:tc>
+                <a:tc>
+                  <a:txBody>
+                    <a:bodyPr wrap="square"/>
+                    <a:lstStyle/>
+                    <a:p>
+                      <a:r>
+                        <a:rPr b="0" sz="1400">
+                          <a:solidFill>
+                            <a:srgbClr val="FFFFFF"/>
+                          </a:solidFill>
+                          <a:latin typeface="Century Gothic"/>
+                        </a:rPr>
+                        <a:t>test('login exitoso', async ({ page }) =&gt; { ... });</a:t>
+                      </a:r>
+                    </a:p>
+                  </a:txBody>
+                  <a:tcPr>
+                    <a:solidFill>
+                      <a:srgbClr val="08264F"/>
+                    </a:solidFill>
+                  </a:tcPr>
+                </a:tc>
+              </a:tr>
+            </a:tbl>
+          </a:graphicData>
+        </a:graphic>
+      </p:graphicFrame>
       <p:sp>
         <p:nvSpPr>
           <p:cNvPr id="5" name="TextBox 4"/>
@@ -4470,8 +4809,8 @@
         </p:nvSpPr>
         <p:spPr>
           <a:xfrm>
-            <a:off x="777240" y="1965960"/>
-            <a:ext cx="3088538" cy="548640"/>
+            <a:off x="548640" y="6400800"/>
+            <a:ext cx="8229600" cy="274320"/>
           </a:xfrm>
           <a:prstGeom prst="rect">
             <a:avLst/>
@@ -4486,13 +4825,13 @@
           <a:p>
             <a:pPr algn="l"/>
             <a:r>
-              <a:rPr b="1" sz="1800">
-                <a:solidFill>
-                  <a:srgbClr val="FFFFFF"/>
-                </a:solidFill>
-                <a:latin typeface="Century Gothic"/>
-              </a:rPr>
-              <a:t>Maneja el navegador</a:t>
+              <a:rPr b="0" sz="1200">
+                <a:solidFill>
+                  <a:srgbClr val="C9D6E3"/>
+                </a:solidFill>
+                <a:latin typeface="Century Gothic"/>
+              </a:rPr>
+              <a:t>Semillero QA 2026 · Clase 4 · Playwright y POM</a:t>
             </a:r>
           </a:p>
         </p:txBody>
@@ -4500,306 +4839,6 @@
       <p:sp>
         <p:nvSpPr>
           <p:cNvPr id="6" name="TextBox 5"/>
-          <p:cNvSpPr txBox="1"/>
-          <p:nvPr/>
-        </p:nvSpPr>
-        <p:spPr>
-          <a:xfrm>
-            <a:off x="777240" y="2468880"/>
-            <a:ext cx="3088538" cy="3474720"/>
-          </a:xfrm>
-          <a:prstGeom prst="rect">
-            <a:avLst/>
-          </a:prstGeom>
-          <a:noFill/>
-        </p:spPr>
-        <p:txBody>
-          <a:bodyPr wrap="square" anchor="t" lIns="0" rIns="0">
-            <a:spAutoFit/>
-          </a:bodyPr>
-          <a:lstStyle/>
-          <a:p>
-            <a:pPr algn="l"/>
-            <a:r>
-              <a:rPr b="0" sz="1400">
-                <a:solidFill>
-                  <a:srgbClr val="C9D6E3"/>
-                </a:solidFill>
-                <a:latin typeface="Century Gothic"/>
-              </a:rPr>
-              <a:t>Abre Chromium, escribe, hace clic y lee textos desde código Java.</a:t>
-            </a:r>
-          </a:p>
-        </p:txBody>
-      </p:sp>
-      <p:sp>
-        <p:nvSpPr>
-          <p:cNvPr id="7" name="Rounded Rectangle 6"/>
-          <p:cNvSpPr/>
-          <p:nvPr/>
-        </p:nvSpPr>
-        <p:spPr>
-          <a:xfrm>
-            <a:off x="4322978" y="1737360"/>
-            <a:ext cx="3545738" cy="4389120"/>
-          </a:xfrm>
-          <a:prstGeom prst="roundRect">
-            <a:avLst>
-              <a:gd name="adj" fmla="val 6000"/>
-            </a:avLst>
-          </a:prstGeom>
-          <a:solidFill>
-            <a:srgbClr val="08264F"/>
-          </a:solidFill>
-          <a:ln w="15875">
-            <a:solidFill>
-              <a:srgbClr val="5EA7D8"/>
-            </a:solidFill>
-          </a:ln>
-        </p:spPr>
-        <p:style>
-          <a:lnRef idx="1">
-            <a:schemeClr val="accent1"/>
-          </a:lnRef>
-          <a:fillRef idx="3">
-            <a:schemeClr val="accent1"/>
-          </a:fillRef>
-          <a:effectRef idx="2">
-            <a:schemeClr val="accent1"/>
-          </a:effectRef>
-          <a:fontRef idx="minor">
-            <a:schemeClr val="lt1"/>
-          </a:fontRef>
-        </p:style>
-        <p:txBody>
-          <a:bodyPr rtlCol="0" anchor="ctr"/>
-          <a:lstStyle/>
-          <a:p/>
-        </p:txBody>
-      </p:sp>
-      <p:sp>
-        <p:nvSpPr>
-          <p:cNvPr id="8" name="TextBox 7"/>
-          <p:cNvSpPr txBox="1"/>
-          <p:nvPr/>
-        </p:nvSpPr>
-        <p:spPr>
-          <a:xfrm>
-            <a:off x="4551578" y="1965960"/>
-            <a:ext cx="3088538" cy="548640"/>
-          </a:xfrm>
-          <a:prstGeom prst="rect">
-            <a:avLst/>
-          </a:prstGeom>
-          <a:noFill/>
-        </p:spPr>
-        <p:txBody>
-          <a:bodyPr wrap="square" anchor="t" lIns="0" rIns="0">
-            <a:spAutoFit/>
-          </a:bodyPr>
-          <a:lstStyle/>
-          <a:p>
-            <a:pPr algn="l"/>
-            <a:r>
-              <a:rPr b="1" sz="1800">
-                <a:solidFill>
-                  <a:srgbClr val="FFFFFF"/>
-                </a:solidFill>
-                <a:latin typeface="Century Gothic"/>
-              </a:rPr>
-              <a:t>Localizadores</a:t>
-            </a:r>
-          </a:p>
-        </p:txBody>
-      </p:sp>
-      <p:sp>
-        <p:nvSpPr>
-          <p:cNvPr id="9" name="TextBox 8"/>
-          <p:cNvSpPr txBox="1"/>
-          <p:nvPr/>
-        </p:nvSpPr>
-        <p:spPr>
-          <a:xfrm>
-            <a:off x="4551578" y="2468880"/>
-            <a:ext cx="3088538" cy="3474720"/>
-          </a:xfrm>
-          <a:prstGeom prst="rect">
-            <a:avLst/>
-          </a:prstGeom>
-          <a:noFill/>
-        </p:spPr>
-        <p:txBody>
-          <a:bodyPr wrap="square" anchor="t" lIns="0" rIns="0">
-            <a:spAutoFit/>
-          </a:bodyPr>
-          <a:lstStyle/>
-          <a:p>
-            <a:pPr algn="l"/>
-            <a:r>
-              <a:rPr b="0" sz="1400">
-                <a:solidFill>
-                  <a:srgbClr val="C9D6E3"/>
-                </a:solidFill>
-                <a:latin typeface="Century Gothic"/>
-              </a:rPr>
-              <a:t>Encuentran elementos por texto gris, por rol y nombre, o por el atributo data-test.</a:t>
-            </a:r>
-          </a:p>
-        </p:txBody>
-      </p:sp>
-      <p:sp>
-        <p:nvSpPr>
-          <p:cNvPr id="10" name="Rounded Rectangle 9"/>
-          <p:cNvSpPr/>
-          <p:nvPr/>
-        </p:nvSpPr>
-        <p:spPr>
-          <a:xfrm>
-            <a:off x="8097316" y="1737360"/>
-            <a:ext cx="3545738" cy="4389120"/>
-          </a:xfrm>
-          <a:prstGeom prst="roundRect">
-            <a:avLst>
-              <a:gd name="adj" fmla="val 6000"/>
-            </a:avLst>
-          </a:prstGeom>
-          <a:solidFill>
-            <a:srgbClr val="0B2C59"/>
-          </a:solidFill>
-          <a:ln w="15875">
-            <a:solidFill>
-              <a:srgbClr val="5EA7D8"/>
-            </a:solidFill>
-          </a:ln>
-        </p:spPr>
-        <p:style>
-          <a:lnRef idx="1">
-            <a:schemeClr val="accent1"/>
-          </a:lnRef>
-          <a:fillRef idx="3">
-            <a:schemeClr val="accent1"/>
-          </a:fillRef>
-          <a:effectRef idx="2">
-            <a:schemeClr val="accent1"/>
-          </a:effectRef>
-          <a:fontRef idx="minor">
-            <a:schemeClr val="lt1"/>
-          </a:fontRef>
-        </p:style>
-        <p:txBody>
-          <a:bodyPr rtlCol="0" anchor="ctr"/>
-          <a:lstStyle/>
-          <a:p/>
-        </p:txBody>
-      </p:sp>
-      <p:sp>
-        <p:nvSpPr>
-          <p:cNvPr id="11" name="TextBox 10"/>
-          <p:cNvSpPr txBox="1"/>
-          <p:nvPr/>
-        </p:nvSpPr>
-        <p:spPr>
-          <a:xfrm>
-            <a:off x="8325916" y="1965960"/>
-            <a:ext cx="3088538" cy="548640"/>
-          </a:xfrm>
-          <a:prstGeom prst="rect">
-            <a:avLst/>
-          </a:prstGeom>
-          <a:noFill/>
-        </p:spPr>
-        <p:txBody>
-          <a:bodyPr wrap="square" anchor="t" lIns="0" rIns="0">
-            <a:spAutoFit/>
-          </a:bodyPr>
-          <a:lstStyle/>
-          <a:p>
-            <a:pPr algn="l"/>
-            <a:r>
-              <a:rPr b="1" sz="1800">
-                <a:solidFill>
-                  <a:srgbClr val="FFFFFF"/>
-                </a:solidFill>
-                <a:latin typeface="Century Gothic"/>
-              </a:rPr>
-              <a:t>Espera solo</a:t>
-            </a:r>
-          </a:p>
-        </p:txBody>
-      </p:sp>
-      <p:sp>
-        <p:nvSpPr>
-          <p:cNvPr id="12" name="TextBox 11"/>
-          <p:cNvSpPr txBox="1"/>
-          <p:nvPr/>
-        </p:nvSpPr>
-        <p:spPr>
-          <a:xfrm>
-            <a:off x="8325916" y="2468880"/>
-            <a:ext cx="3088538" cy="3474720"/>
-          </a:xfrm>
-          <a:prstGeom prst="rect">
-            <a:avLst/>
-          </a:prstGeom>
-          <a:noFill/>
-        </p:spPr>
-        <p:txBody>
-          <a:bodyPr wrap="square" anchor="t" lIns="0" rIns="0">
-            <a:spAutoFit/>
-          </a:bodyPr>
-          <a:lstStyle/>
-          <a:p>
-            <a:pPr algn="l"/>
-            <a:r>
-              <a:rPr b="0" sz="1400">
-                <a:solidFill>
-                  <a:srgbClr val="C9D6E3"/>
-                </a:solidFill>
-                <a:latin typeface="Century Gothic"/>
-              </a:rPr>
-              <a:t>Antes de cada acción espera a que el elemento aparezca. Si no aparece en 30 s, falla.</a:t>
-            </a:r>
-          </a:p>
-        </p:txBody>
-      </p:sp>
-      <p:sp>
-        <p:nvSpPr>
-          <p:cNvPr id="13" name="TextBox 12"/>
-          <p:cNvSpPr txBox="1"/>
-          <p:nvPr/>
-        </p:nvSpPr>
-        <p:spPr>
-          <a:xfrm>
-            <a:off x="548640" y="6400800"/>
-            <a:ext cx="8229600" cy="274320"/>
-          </a:xfrm>
-          <a:prstGeom prst="rect">
-            <a:avLst/>
-          </a:prstGeom>
-          <a:noFill/>
-        </p:spPr>
-        <p:txBody>
-          <a:bodyPr wrap="square" anchor="t" lIns="0" rIns="0">
-            <a:spAutoFit/>
-          </a:bodyPr>
-          <a:lstStyle/>
-          <a:p>
-            <a:pPr algn="l"/>
-            <a:r>
-              <a:rPr b="0" sz="1200">
-                <a:solidFill>
-                  <a:srgbClr val="C9D6E3"/>
-                </a:solidFill>
-                <a:latin typeface="Century Gothic"/>
-              </a:rPr>
-              <a:t>Semillero QA 2026 · Clase 4 · Playwright y POM</a:t>
-            </a:r>
-          </a:p>
-        </p:txBody>
-      </p:sp>
-      <p:sp>
-        <p:nvSpPr>
-          <p:cNvPr id="14" name="TextBox 13"/>
           <p:cNvSpPr txBox="1"/>
           <p:nvPr/>
         </p:nvSpPr>
@@ -4867,7 +4906,7 @@
         <p:spPr>
           <a:xfrm>
             <a:off x="548640" y="411480"/>
-            <a:ext cx="1956816" cy="329184"/>
+            <a:ext cx="768096" cy="329184"/>
           </a:xfrm>
           <a:prstGeom prst="roundRect">
             <a:avLst>
@@ -4907,7 +4946,7 @@
                 </a:solidFill>
                 <a:latin typeface="Century Gothic"/>
               </a:rPr>
-              <a:t>LOCALIZADORES</a:t>
+              <a:t>POM</a:t>
             </a:r>
           </a:p>
         </p:txBody>
@@ -4942,7 +4981,7 @@
                 </a:solidFill>
                 <a:latin typeface="Century Gothic"/>
               </a:rPr>
-              <a:t>Tres formas de localizar</a:t>
+              <a:t>LoginPage: el control remoto</a:t>
             </a:r>
           </a:p>
         </p:txBody>
@@ -5024,7 +5063,7 @@
                 </a:solidFill>
                 <a:latin typeface="Century Gothic"/>
               </a:rPr>
-              <a:t>Java</a:t>
+              <a:t>TypeScript, resumido</a:t>
             </a:r>
           </a:p>
         </p:txBody>
@@ -5058,7 +5097,7 @@
                 </a:solidFill>
                 <a:latin typeface="Consolas"/>
               </a:rPr>
-              <a:t>campoUsuario = pagina.getByPlaceholder("Username");</a:t>
+              <a:t>export class LoginPage {</a:t>
             </a:r>
           </a:p>
           <a:p>
@@ -5069,6 +5108,50 @@
                 </a:solidFill>
                 <a:latin typeface="Consolas"/>
               </a:rPr>
+              <a:t>  private readonly campoUsuario: Locator;</a:t>
+            </a:r>
+          </a:p>
+          <a:p>
+            <a:r>
+              <a:rPr sz="1300">
+                <a:solidFill>
+                  <a:srgbClr val="FFFFFF"/>
+                </a:solidFill>
+                <a:latin typeface="Consolas"/>
+              </a:rPr>
+              <a:t>  private readonly campoClave: Locator;</a:t>
+            </a:r>
+          </a:p>
+          <a:p>
+            <a:r>
+              <a:rPr sz="1300">
+                <a:solidFill>
+                  <a:srgbClr val="FFFFFF"/>
+                </a:solidFill>
+                <a:latin typeface="Consolas"/>
+              </a:rPr>
+              <a:t>  private readonly botonLogin: Locator;</a:t>
+            </a:r>
+          </a:p>
+          <a:p>
+            <a:r>
+              <a:rPr sz="1300">
+                <a:solidFill>
+                  <a:srgbClr val="FFFFFF"/>
+                </a:solidFill>
+                <a:latin typeface="Consolas"/>
+              </a:rPr>
+              <a:t>  readonly mensajeError: Locator;</a:t>
+            </a:r>
+          </a:p>
+          <a:p>
+            <a:r>
+              <a:rPr sz="1300">
+                <a:solidFill>
+                  <a:srgbClr val="FFFFFF"/>
+                </a:solidFill>
+                <a:latin typeface="Consolas"/>
+              </a:rPr>
               <a:t> </a:t>
             </a:r>
           </a:p>
@@ -5080,7 +5163,7 @@
                 </a:solidFill>
                 <a:latin typeface="Consolas"/>
               </a:rPr>
-              <a:t>campoClave = pagina.getByPlaceholder("Password");</a:t>
+              <a:t>  constructor(page: Page) {</a:t>
             </a:r>
           </a:p>
           <a:p>
@@ -5091,6 +5174,61 @@
                 </a:solidFill>
                 <a:latin typeface="Consolas"/>
               </a:rPr>
+              <a:t>    this.campoUsuario = page.getByPlaceholder('Username');</a:t>
+            </a:r>
+          </a:p>
+          <a:p>
+            <a:r>
+              <a:rPr sz="1300">
+                <a:solidFill>
+                  <a:srgbClr val="FFFFFF"/>
+                </a:solidFill>
+                <a:latin typeface="Consolas"/>
+              </a:rPr>
+              <a:t>    this.campoClave = page.getByPlaceholder('Password');</a:t>
+            </a:r>
+          </a:p>
+          <a:p>
+            <a:r>
+              <a:rPr sz="1300">
+                <a:solidFill>
+                  <a:srgbClr val="FFFFFF"/>
+                </a:solidFill>
+                <a:latin typeface="Consolas"/>
+              </a:rPr>
+              <a:t>    this.botonLogin = page.getByRole('button', { name: 'Login' });</a:t>
+            </a:r>
+          </a:p>
+          <a:p>
+            <a:r>
+              <a:rPr sz="1300">
+                <a:solidFill>
+                  <a:srgbClr val="FFFFFF"/>
+                </a:solidFill>
+                <a:latin typeface="Consolas"/>
+              </a:rPr>
+              <a:t>    this.mensajeError = page.getByTestId('error');</a:t>
+            </a:r>
+          </a:p>
+          <a:p>
+            <a:r>
+              <a:rPr sz="1300">
+                <a:solidFill>
+                  <a:srgbClr val="FFFFFF"/>
+                </a:solidFill>
+                <a:latin typeface="Consolas"/>
+              </a:rPr>
+              <a:t>  }</a:t>
+            </a:r>
+          </a:p>
+          <a:p>
+            <a:r>
+              <a:rPr sz="1300">
+                <a:solidFill>
+                  <a:srgbClr val="FFFFFF"/>
+                </a:solidFill>
+                <a:latin typeface="Consolas"/>
+              </a:rPr>
               <a:t> </a:t>
             </a:r>
           </a:p>
@@ -5102,7 +5240,7 @@
                 </a:solidFill>
                 <a:latin typeface="Consolas"/>
               </a:rPr>
-              <a:t>botonLogin = pagina.getByRole(AriaRole.BUTTON,</a:t>
+              <a:t>  async iniciarSesion(usuario: string, clave: string) {</a:t>
             </a:r>
           </a:p>
           <a:p>
@@ -5113,7 +5251,7 @@
                 </a:solidFill>
                 <a:latin typeface="Consolas"/>
               </a:rPr>
-              <a:t>        new Page.GetByRoleOptions().setName("Login"));</a:t>
+              <a:t>    await this.campoUsuario.fill(usuario);</a:t>
             </a:r>
           </a:p>
           <a:p>
@@ -5124,7 +5262,7 @@
                 </a:solidFill>
                 <a:latin typeface="Consolas"/>
               </a:rPr>
-              <a:t> </a:t>
+              <a:t>    await this.campoClave.fill(clave);</a:t>
             </a:r>
           </a:p>
           <a:p>
@@ -5135,7 +5273,29 @@
                 </a:solidFill>
                 <a:latin typeface="Consolas"/>
               </a:rPr>
-              <a:t>mensajeError = pagina.locator("[data-test='error']");</a:t>
+              <a:t>    await this.botonLogin.click();</a:t>
+            </a:r>
+          </a:p>
+          <a:p>
+            <a:r>
+              <a:rPr sz="1300">
+                <a:solidFill>
+                  <a:srgbClr val="FFFFFF"/>
+                </a:solidFill>
+                <a:latin typeface="Consolas"/>
+              </a:rPr>
+              <a:t>  }</a:t>
+            </a:r>
+          </a:p>
+          <a:p>
+            <a:r>
+              <a:rPr sz="1300">
+                <a:solidFill>
+                  <a:srgbClr val="FFFFFF"/>
+                </a:solidFill>
+                <a:latin typeface="Consolas"/>
+              </a:rPr>
+              <a:t>}</a:t>
             </a:r>
           </a:p>
         </p:txBody>
@@ -5183,7 +5343,7 @@
                 </a:solidFill>
                 <a:latin typeface="Consolas"/>
               </a:rPr>
-              <a:t>getByPlaceholder</a:t>
+              <a:t>private readonly</a:t>
             </a:r>
             <a:r>
               <a:rPr b="0" sz="1600">
@@ -5192,7 +5352,7 @@
                 </a:solidFill>
                 <a:latin typeface="Century Gothic"/>
               </a:rPr>
-              <a:t>: el texto gris del campo</a:t>
+              <a:t>: los cables, la prueba no los ve</a:t>
             </a:r>
           </a:p>
           <a:p>
@@ -5213,11 +5373,20 @@
             <a:r>
               <a:rPr b="0" sz="1600">
                 <a:solidFill>
+                  <a:srgbClr val="FFFFFF"/>
+                </a:solidFill>
+                <a:latin typeface="Century Gothic"/>
+              </a:rPr>
+              <a:t>Métodos </a:t>
+            </a:r>
+            <a:r>
+              <a:rPr b="0" sz="1600">
+                <a:solidFill>
                   <a:srgbClr val="36B5FF"/>
                 </a:solidFill>
                 <a:latin typeface="Consolas"/>
               </a:rPr>
-              <a:t>getByRole</a:t>
+              <a:t>async</a:t>
             </a:r>
             <a:r>
               <a:rPr b="0" sz="1600">
@@ -5226,7 +5395,7 @@
                 </a:solidFill>
                 <a:latin typeface="Century Gothic"/>
               </a:rPr>
-              <a:t>: un botón que dice Login</a:t>
+              <a:t>: los botones</a:t>
             </a:r>
           </a:p>
           <a:p>
@@ -5251,7 +5420,7 @@
                 </a:solidFill>
                 <a:latin typeface="Consolas"/>
               </a:rPr>
-              <a:t>locator</a:t>
+              <a:t>mensajeError</a:t>
             </a:r>
             <a:r>
               <a:rPr b="0" sz="1600">
@@ -5260,7 +5429,7 @@
                 </a:solidFill>
                 <a:latin typeface="Century Gothic"/>
               </a:rPr>
-              <a:t>: un atributo pensado para pruebas</a:t>
+              <a:t> público: la pantallita que la prueba revisa</a:t>
             </a:r>
           </a:p>
           <a:p>
@@ -5281,11 +5450,20 @@
             <a:r>
               <a:rPr b="0" sz="1600">
                 <a:solidFill>
-                  <a:srgbClr val="FFFFFF"/>
-                </a:solidFill>
-                <a:latin typeface="Century Gothic"/>
-              </a:rPr>
-              <a:t>Clic derecho e Inspeccionar en Chrome para ver los atributos</a:t>
+                  <a:srgbClr val="36B5FF"/>
+                </a:solidFill>
+                <a:latin typeface="Consolas"/>
+              </a:rPr>
+              <a:t>await</a:t>
+            </a:r>
+            <a:r>
+              <a:rPr b="0" sz="1600">
+                <a:solidFill>
+                  <a:srgbClr val="FFFFFF"/>
+                </a:solidFill>
+                <a:latin typeface="Century Gothic"/>
+              </a:rPr>
+              <a:t>: espera a que termine, como en la fila del banco</a:t>
             </a:r>
           </a:p>
         </p:txBody>
@@ -5470,56 +5648,21 @@
                 </a:solidFill>
                 <a:latin typeface="Century Gothic"/>
               </a:rPr>
-              <a:t>POM: un control remoto por pantalla</a:t>
-            </a:r>
-          </a:p>
-        </p:txBody>
-      </p:sp>
-      <p:sp>
-        <p:nvSpPr>
-          <p:cNvPr id="4" name="TextBox 3"/>
-          <p:cNvSpPr txBox="1"/>
-          <p:nvPr/>
-        </p:nvSpPr>
-        <p:spPr>
-          <a:xfrm>
-            <a:off x="548640" y="1645920"/>
-            <a:ext cx="11094415" cy="548640"/>
-          </a:xfrm>
-          <a:prstGeom prst="rect">
-            <a:avLst/>
-          </a:prstGeom>
-          <a:noFill/>
-        </p:spPr>
-        <p:txBody>
-          <a:bodyPr wrap="square" anchor="t" lIns="0" rIns="0">
-            <a:spAutoFit/>
-          </a:bodyPr>
-          <a:lstStyle/>
-          <a:p>
-            <a:pPr algn="l"/>
-            <a:r>
-              <a:rPr b="0" sz="1600">
-                <a:solidFill>
-                  <a:srgbClr val="C9D6E3"/>
-                </a:solidFill>
-                <a:latin typeface="Century Gothic"/>
-              </a:rPr>
-              <a:t>La prueba aprieta botones. Nunca toca los cables.</a:t>
-            </a:r>
-          </a:p>
-        </p:txBody>
-      </p:sp>
-      <p:sp>
-        <p:nvSpPr>
-          <p:cNvPr id="5" name="Rounded Rectangle 4"/>
+              <a:t>Quién habla con quién</a:t>
+            </a:r>
+          </a:p>
+        </p:txBody>
+      </p:sp>
+      <p:sp>
+        <p:nvSpPr>
+          <p:cNvPr id="4" name="Rounded Rectangle 3"/>
           <p:cNvSpPr/>
           <p:nvPr/>
         </p:nvSpPr>
         <p:spPr>
           <a:xfrm>
-            <a:off x="548640" y="2286000"/>
-            <a:ext cx="3545738" cy="3840480"/>
+            <a:off x="548640" y="2057400"/>
+            <a:ext cx="2464993" cy="2651760"/>
           </a:xfrm>
           <a:prstGeom prst="roundRect">
             <a:avLst>
@@ -5557,14 +5700,14 @@
       </p:sp>
       <p:sp>
         <p:nvSpPr>
-          <p:cNvPr id="6" name="TextBox 5"/>
+          <p:cNvPr id="5" name="TextBox 4"/>
           <p:cNvSpPr txBox="1"/>
           <p:nvPr/>
         </p:nvSpPr>
         <p:spPr>
           <a:xfrm>
-            <a:off x="777240" y="2514600"/>
-            <a:ext cx="3088538" cy="548640"/>
+            <a:off x="777240" y="2286000"/>
+            <a:ext cx="2007793" cy="548640"/>
           </a:xfrm>
           <a:prstGeom prst="rect">
             <a:avLst/>
@@ -5585,21 +5728,21 @@
                 </a:solidFill>
                 <a:latin typeface="Century Gothic"/>
               </a:rPr>
-              <a:t>PaginaBase</a:t>
-            </a:r>
-          </a:p>
-        </p:txBody>
-      </p:sp>
-      <p:sp>
-        <p:nvSpPr>
-          <p:cNvPr id="7" name="TextBox 6"/>
+              <a:t>login.spec.ts</a:t>
+            </a:r>
+          </a:p>
+        </p:txBody>
+      </p:sp>
+      <p:sp>
+        <p:nvSpPr>
+          <p:cNvPr id="6" name="TextBox 5"/>
           <p:cNvSpPr txBox="1"/>
           <p:nvPr/>
         </p:nvSpPr>
         <p:spPr>
           <a:xfrm>
-            <a:off x="777240" y="3017520"/>
-            <a:ext cx="3088538" cy="2926080"/>
+            <a:off x="777240" y="2788920"/>
+            <a:ext cx="2007793" cy="1737360"/>
           </a:xfrm>
           <a:prstGeom prst="rect">
             <a:avLst/>
@@ -5620,11 +5763,47 @@
                 </a:solidFill>
                 <a:latin typeface="Century Gothic"/>
               </a:rPr>
-              <a:t>La clase padre. Guarda la pestaña y sabe navegar. Las demás la heredan.</a:t>
-            </a:r>
-          </a:p>
-        </p:txBody>
-      </p:sp>
+              <a:t>La prueba. Dice qué hacer y qué revisar.</a:t>
+            </a:r>
+          </a:p>
+        </p:txBody>
+      </p:sp>
+      <p:cxnSp>
+        <p:nvCxnSpPr>
+          <p:cNvPr id="7" name="Connector 6"/>
+          <p:cNvCxnSpPr/>
+          <p:nvPr/>
+        </p:nvCxnSpPr>
+        <p:spPr>
+          <a:xfrm>
+            <a:off x="3059353" y="3383280"/>
+            <a:ext cx="320040" cy="0"/>
+          </a:xfrm>
+          <a:prstGeom prst="line">
+            <a:avLst/>
+          </a:prstGeom>
+          <a:ln w="31750">
+            <a:solidFill>
+              <a:srgbClr val="36B5FF"/>
+            </a:solidFill>
+            <a:tailEnd type="triangle"/>
+          </a:ln>
+        </p:spPr>
+        <p:style>
+          <a:lnRef idx="2">
+            <a:schemeClr val="accent1"/>
+          </a:lnRef>
+          <a:fillRef idx="0">
+            <a:schemeClr val="accent1"/>
+          </a:fillRef>
+          <a:effectRef idx="1">
+            <a:schemeClr val="accent1"/>
+          </a:effectRef>
+          <a:fontRef idx="minor">
+            <a:schemeClr val="tx1"/>
+          </a:fontRef>
+        </p:style>
+      </p:cxnSp>
       <p:sp>
         <p:nvSpPr>
           <p:cNvPr id="8" name="Rounded Rectangle 7"/>
@@ -5633,8 +5812,8 @@
         </p:nvSpPr>
         <p:spPr>
           <a:xfrm>
-            <a:off x="4322978" y="2286000"/>
-            <a:ext cx="3545738" cy="3840480"/>
+            <a:off x="3425113" y="2057400"/>
+            <a:ext cx="2464993" cy="2651760"/>
           </a:xfrm>
           <a:prstGeom prst="roundRect">
             <a:avLst>
@@ -5678,8 +5857,8 @@
         </p:nvSpPr>
         <p:spPr>
           <a:xfrm>
-            <a:off x="4551578" y="2514600"/>
-            <a:ext cx="3088538" cy="548640"/>
+            <a:off x="3653713" y="2286000"/>
+            <a:ext cx="2007793" cy="548640"/>
           </a:xfrm>
           <a:prstGeom prst="rect">
             <a:avLst/>
@@ -5713,8 +5892,8 @@
         </p:nvSpPr>
         <p:spPr>
           <a:xfrm>
-            <a:off x="4551578" y="3017520"/>
-            <a:ext cx="3088538" cy="2926080"/>
+            <a:off x="3653713" y="2788920"/>
+            <a:ext cx="2007793" cy="1737360"/>
           </a:xfrm>
           <a:prstGeom prst="rect">
             <a:avLst/>
@@ -5735,36 +5914,57 @@
                 </a:solidFill>
                 <a:latin typeface="Century Gothic"/>
               </a:rPr>
-              <a:t>Botones: abrir(), iniciarSesion(usuario, clave) y mensajeDeError()</a:t>
-            </a:r>
-          </a:p>
-          <a:p>
-            <a:pPr algn="l"/>
-          </a:p>
-          <a:p>
-            <a:pPr algn="l"/>
-            <a:r>
-              <a:rPr b="0" sz="1400">
-                <a:solidFill>
-                  <a:srgbClr val="C9D6E3"/>
-                </a:solidFill>
-                <a:latin typeface="Century Gothic"/>
-              </a:rPr>
-              <a:t>Cables privados: los localizadores</a:t>
-            </a:r>
-          </a:p>
-        </p:txBody>
-      </p:sp>
-      <p:sp>
-        <p:nvSpPr>
-          <p:cNvPr id="11" name="Rounded Rectangle 10"/>
+              <a:t>Traduce iniciarSesion() a escribir y hacer clic.</a:t>
+            </a:r>
+          </a:p>
+        </p:txBody>
+      </p:sp>
+      <p:cxnSp>
+        <p:nvCxnSpPr>
+          <p:cNvPr id="11" name="Connector 10"/>
+          <p:cNvCxnSpPr/>
+          <p:nvPr/>
+        </p:nvCxnSpPr>
+        <p:spPr>
+          <a:xfrm>
+            <a:off x="5935826" y="3383280"/>
+            <a:ext cx="320040" cy="0"/>
+          </a:xfrm>
+          <a:prstGeom prst="line">
+            <a:avLst/>
+          </a:prstGeom>
+          <a:ln w="31750">
+            <a:solidFill>
+              <a:srgbClr val="36B5FF"/>
+            </a:solidFill>
+            <a:tailEnd type="triangle"/>
+          </a:ln>
+        </p:spPr>
+        <p:style>
+          <a:lnRef idx="2">
+            <a:schemeClr val="accent1"/>
+          </a:lnRef>
+          <a:fillRef idx="0">
+            <a:schemeClr val="accent1"/>
+          </a:fillRef>
+          <a:effectRef idx="1">
+            <a:schemeClr val="accent1"/>
+          </a:effectRef>
+          <a:fontRef idx="minor">
+            <a:schemeClr val="tx1"/>
+          </a:fontRef>
+        </p:style>
+      </p:cxnSp>
+      <p:sp>
+        <p:nvSpPr>
+          <p:cNvPr id="12" name="Rounded Rectangle 11"/>
           <p:cNvSpPr/>
           <p:nvPr/>
         </p:nvSpPr>
         <p:spPr>
           <a:xfrm>
-            <a:off x="8097316" y="2286000"/>
-            <a:ext cx="3545738" cy="3840480"/>
+            <a:off x="6301586" y="2057400"/>
+            <a:ext cx="2464993" cy="2651760"/>
           </a:xfrm>
           <a:prstGeom prst="roundRect">
             <a:avLst>
@@ -5802,14 +6002,14 @@
       </p:sp>
       <p:sp>
         <p:nvSpPr>
-          <p:cNvPr id="12" name="TextBox 11"/>
+          <p:cNvPr id="13" name="TextBox 12"/>
           <p:cNvSpPr txBox="1"/>
           <p:nvPr/>
         </p:nvSpPr>
         <p:spPr>
           <a:xfrm>
-            <a:off x="8325916" y="2514600"/>
-            <a:ext cx="3088538" cy="548640"/>
+            <a:off x="6530186" y="2286000"/>
+            <a:ext cx="2007793" cy="548640"/>
           </a:xfrm>
           <a:prstGeom prst="rect">
             <a:avLst/>
@@ -5830,21 +6030,21 @@
                 </a:solidFill>
                 <a:latin typeface="Century Gothic"/>
               </a:rPr>
-              <a:t>ProductosPage</a:t>
-            </a:r>
-          </a:p>
-        </p:txBody>
-      </p:sp>
-      <p:sp>
-        <p:nvSpPr>
-          <p:cNvPr id="13" name="TextBox 12"/>
+              <a:t>Playwright</a:t>
+            </a:r>
+          </a:p>
+        </p:txBody>
+      </p:sp>
+      <p:sp>
+        <p:nvSpPr>
+          <p:cNvPr id="14" name="TextBox 13"/>
           <p:cNvSpPr txBox="1"/>
           <p:nvPr/>
         </p:nvSpPr>
         <p:spPr>
           <a:xfrm>
-            <a:off x="8325916" y="3017520"/>
-            <a:ext cx="3088538" cy="2926080"/>
+            <a:off x="6530186" y="2788920"/>
+            <a:ext cx="2007793" cy="1737360"/>
           </a:xfrm>
           <a:prstGeom prst="rect">
             <a:avLst/>
@@ -5865,36 +6065,102 @@
                 </a:solidFill>
                 <a:latin typeface="Century Gothic"/>
               </a:rPr>
-              <a:t>Botón: titulo()</a:t>
-            </a:r>
-          </a:p>
-          <a:p>
-            <a:pPr algn="l"/>
-          </a:p>
-          <a:p>
-            <a:pPr algn="l"/>
-            <a:r>
-              <a:rPr b="0" sz="1400">
-                <a:solidFill>
-                  <a:srgbClr val="C9D6E3"/>
-                </a:solidFill>
-                <a:latin typeface="Century Gothic"/>
-              </a:rPr>
-              <a:t>Si el login funcionó, devuelve Products</a:t>
-            </a:r>
-          </a:p>
-        </p:txBody>
-      </p:sp>
-      <p:sp>
-        <p:nvSpPr>
-          <p:cNvPr id="14" name="TextBox 13"/>
+              <a:t>Busca el elemento, espera y actúa.</a:t>
+            </a:r>
+          </a:p>
+        </p:txBody>
+      </p:sp>
+      <p:cxnSp>
+        <p:nvCxnSpPr>
+          <p:cNvPr id="15" name="Connector 14"/>
+          <p:cNvCxnSpPr/>
+          <p:nvPr/>
+        </p:nvCxnSpPr>
+        <p:spPr>
+          <a:xfrm>
+            <a:off x="8812299" y="3383280"/>
+            <a:ext cx="320040" cy="0"/>
+          </a:xfrm>
+          <a:prstGeom prst="line">
+            <a:avLst/>
+          </a:prstGeom>
+          <a:ln w="31750">
+            <a:solidFill>
+              <a:srgbClr val="36B5FF"/>
+            </a:solidFill>
+            <a:tailEnd type="triangle"/>
+          </a:ln>
+        </p:spPr>
+        <p:style>
+          <a:lnRef idx="2">
+            <a:schemeClr val="accent1"/>
+          </a:lnRef>
+          <a:fillRef idx="0">
+            <a:schemeClr val="accent1"/>
+          </a:fillRef>
+          <a:effectRef idx="1">
+            <a:schemeClr val="accent1"/>
+          </a:effectRef>
+          <a:fontRef idx="minor">
+            <a:schemeClr val="tx1"/>
+          </a:fontRef>
+        </p:style>
+      </p:cxnSp>
+      <p:sp>
+        <p:nvSpPr>
+          <p:cNvPr id="16" name="Rounded Rectangle 15"/>
+          <p:cNvSpPr/>
+          <p:nvPr/>
+        </p:nvSpPr>
+        <p:spPr>
+          <a:xfrm>
+            <a:off x="9178059" y="2057400"/>
+            <a:ext cx="2464993" cy="2651760"/>
+          </a:xfrm>
+          <a:prstGeom prst="roundRect">
+            <a:avLst>
+              <a:gd name="adj" fmla="val 6000"/>
+            </a:avLst>
+          </a:prstGeom>
+          <a:solidFill>
+            <a:srgbClr val="08264F"/>
+          </a:solidFill>
+          <a:ln w="15875">
+            <a:solidFill>
+              <a:srgbClr val="5EA7D8"/>
+            </a:solidFill>
+          </a:ln>
+        </p:spPr>
+        <p:style>
+          <a:lnRef idx="1">
+            <a:schemeClr val="accent1"/>
+          </a:lnRef>
+          <a:fillRef idx="3">
+            <a:schemeClr val="accent1"/>
+          </a:fillRef>
+          <a:effectRef idx="2">
+            <a:schemeClr val="accent1"/>
+          </a:effectRef>
+          <a:fontRef idx="minor">
+            <a:schemeClr val="lt1"/>
+          </a:fontRef>
+        </p:style>
+        <p:txBody>
+          <a:bodyPr rtlCol="0" anchor="ctr"/>
+          <a:lstStyle/>
+          <a:p/>
+        </p:txBody>
+      </p:sp>
+      <p:sp>
+        <p:nvSpPr>
+          <p:cNvPr id="17" name="TextBox 16"/>
           <p:cNvSpPr txBox="1"/>
           <p:nvPr/>
         </p:nvSpPr>
         <p:spPr>
           <a:xfrm>
-            <a:off x="548640" y="6400800"/>
-            <a:ext cx="8229600" cy="274320"/>
+            <a:off x="9406659" y="2286000"/>
+            <a:ext cx="2007793" cy="548640"/>
           </a:xfrm>
           <a:prstGeom prst="rect">
             <a:avLst/>
@@ -5909,6 +6175,111 @@
           <a:p>
             <a:pPr algn="l"/>
             <a:r>
+              <a:rPr b="1" sz="1800">
+                <a:solidFill>
+                  <a:srgbClr val="FFFFFF"/>
+                </a:solidFill>
+                <a:latin typeface="Century Gothic"/>
+              </a:rPr>
+              <a:t>Chromium</a:t>
+            </a:r>
+          </a:p>
+        </p:txBody>
+      </p:sp>
+      <p:sp>
+        <p:nvSpPr>
+          <p:cNvPr id="18" name="TextBox 17"/>
+          <p:cNvSpPr txBox="1"/>
+          <p:nvPr/>
+        </p:nvSpPr>
+        <p:spPr>
+          <a:xfrm>
+            <a:off x="9406659" y="2788920"/>
+            <a:ext cx="2007793" cy="1737360"/>
+          </a:xfrm>
+          <a:prstGeom prst="rect">
+            <a:avLst/>
+          </a:prstGeom>
+          <a:noFill/>
+        </p:spPr>
+        <p:txBody>
+          <a:bodyPr wrap="square" anchor="t" lIns="0" rIns="0">
+            <a:spAutoFit/>
+          </a:bodyPr>
+          <a:lstStyle/>
+          <a:p>
+            <a:pPr algn="l"/>
+            <a:r>
+              <a:rPr b="0" sz="1400">
+                <a:solidFill>
+                  <a:srgbClr val="C9D6E3"/>
+                </a:solidFill>
+                <a:latin typeface="Century Gothic"/>
+              </a:rPr>
+              <a:t>Abre saucedemo.com y muestra el resultado.</a:t>
+            </a:r>
+          </a:p>
+        </p:txBody>
+      </p:sp>
+      <p:sp>
+        <p:nvSpPr>
+          <p:cNvPr id="19" name="TextBox 18"/>
+          <p:cNvSpPr txBox="1"/>
+          <p:nvPr/>
+        </p:nvSpPr>
+        <p:spPr>
+          <a:xfrm>
+            <a:off x="548640" y="5029200"/>
+            <a:ext cx="11094415" cy="1097280"/>
+          </a:xfrm>
+          <a:prstGeom prst="rect">
+            <a:avLst/>
+          </a:prstGeom>
+          <a:noFill/>
+        </p:spPr>
+        <p:txBody>
+          <a:bodyPr wrap="square" anchor="t" lIns="0" rIns="0">
+            <a:spAutoFit/>
+          </a:bodyPr>
+          <a:lstStyle/>
+          <a:p>
+            <a:pPr algn="l"/>
+            <a:r>
+              <a:rPr b="0" sz="1600">
+                <a:solidFill>
+                  <a:srgbClr val="C9D6E3"/>
+                </a:solidFill>
+                <a:latin typeface="Century Gothic"/>
+              </a:rPr>
+              <a:t>usuarios.ts le pasa los datos a la prueba. Playwright abre una pestaña limpia para cada test.</a:t>
+            </a:r>
+          </a:p>
+        </p:txBody>
+      </p:sp>
+      <p:sp>
+        <p:nvSpPr>
+          <p:cNvPr id="20" name="TextBox 19"/>
+          <p:cNvSpPr txBox="1"/>
+          <p:nvPr/>
+        </p:nvSpPr>
+        <p:spPr>
+          <a:xfrm>
+            <a:off x="548640" y="6400800"/>
+            <a:ext cx="8229600" cy="274320"/>
+          </a:xfrm>
+          <a:prstGeom prst="rect">
+            <a:avLst/>
+          </a:prstGeom>
+          <a:noFill/>
+        </p:spPr>
+        <p:txBody>
+          <a:bodyPr wrap="square" anchor="t" lIns="0" rIns="0">
+            <a:spAutoFit/>
+          </a:bodyPr>
+          <a:lstStyle/>
+          <a:p>
+            <a:pPr algn="l"/>
+            <a:r>
               <a:rPr b="0" sz="1200">
                 <a:solidFill>
                   <a:srgbClr val="C9D6E3"/>
@@ -5922,7 +6293,7 @@
       </p:sp>
       <p:sp>
         <p:nvSpPr>
-          <p:cNvPr id="15" name="TextBox 14"/>
+          <p:cNvPr id="21" name="TextBox 20"/>
           <p:cNvSpPr txBox="1"/>
           <p:nvPr/>
         </p:nvSpPr>
@@ -5990,7 +6361,7 @@
         <p:spPr>
           <a:xfrm>
             <a:off x="548640" y="411480"/>
-            <a:ext cx="768096" cy="329184"/>
+            <a:ext cx="1243584" cy="329184"/>
           </a:xfrm>
           <a:prstGeom prst="roundRect">
             <a:avLst>
@@ -6030,7 +6401,7 @@
                 </a:solidFill>
                 <a:latin typeface="Century Gothic"/>
               </a:rPr>
-              <a:t>POM</a:t>
+              <a:t>PRUEBAS</a:t>
             </a:r>
           </a:p>
         </p:txBody>
@@ -6065,7 +6436,7 @@
                 </a:solidFill>
                 <a:latin typeface="Century Gothic"/>
               </a:rPr>
-              <a:t>Quién habla con quién</a:t>
+              <a:t>Una prueba con POM</a:t>
             </a:r>
           </a:p>
         </p:txBody>
@@ -6078,18 +6449,18 @@
         </p:nvSpPr>
         <p:spPr>
           <a:xfrm>
-            <a:off x="548640" y="2057400"/>
-            <a:ext cx="2464993" cy="2651760"/>
+            <a:off x="548640" y="1737360"/>
+            <a:ext cx="6949440" cy="4389120"/>
           </a:xfrm>
           <a:prstGeom prst="roundRect">
             <a:avLst>
-              <a:gd name="adj" fmla="val 6000"/>
+              <a:gd name="adj" fmla="val 3000"/>
             </a:avLst>
           </a:prstGeom>
           <a:solidFill>
-            <a:srgbClr val="0B2C59"/>
+            <a:srgbClr val="0A1B33"/>
           </a:solidFill>
-          <a:ln w="15875">
+          <a:ln w="12700">
             <a:solidFill>
               <a:srgbClr val="5EA7D8"/>
             </a:solidFill>
@@ -6112,7 +6483,9 @@
         <p:txBody>
           <a:bodyPr rtlCol="0" anchor="ctr"/>
           <a:lstStyle/>
-          <a:p/>
+          <a:p>
+            <a:pPr algn="ctr"/>
+          </a:p>
         </p:txBody>
       </p:sp>
       <p:sp>
@@ -6123,8 +6496,8 @@
         </p:nvSpPr>
         <p:spPr>
           <a:xfrm>
-            <a:off x="777240" y="2286000"/>
-            <a:ext cx="2007793" cy="548640"/>
+            <a:off x="777240" y="1847088"/>
+            <a:ext cx="2743200" cy="274320"/>
           </a:xfrm>
           <a:prstGeom prst="rect">
             <a:avLst/>
@@ -6139,13 +6512,13 @@
           <a:p>
             <a:pPr algn="l"/>
             <a:r>
-              <a:rPr b="1" sz="1800">
-                <a:solidFill>
-                  <a:srgbClr val="FFFFFF"/>
-                </a:solidFill>
-                <a:latin typeface="Century Gothic"/>
-              </a:rPr>
-              <a:t>LoginTest</a:t>
+              <a:rPr b="1" sz="1200">
+                <a:solidFill>
+                  <a:srgbClr val="36B5FF"/>
+                </a:solidFill>
+                <a:latin typeface="Century Gothic"/>
+              </a:rPr>
+              <a:t>TypeScript</a:t>
             </a:r>
           </a:p>
         </p:txBody>
@@ -6158,8 +6531,266 @@
         </p:nvSpPr>
         <p:spPr>
           <a:xfrm>
-            <a:off x="777240" y="2788920"/>
-            <a:ext cx="2007793" cy="1737360"/>
+            <a:off x="777240" y="2194560"/>
+            <a:ext cx="6492240" cy="3840480"/>
+          </a:xfrm>
+          <a:prstGeom prst="rect">
+            <a:avLst/>
+          </a:prstGeom>
+          <a:noFill/>
+        </p:spPr>
+        <p:txBody>
+          <a:bodyPr wrap="square">
+            <a:spAutoFit/>
+          </a:bodyPr>
+          <a:lstStyle/>
+          <a:p>
+            <a:r>
+              <a:rPr sz="1300">
+                <a:solidFill>
+                  <a:srgbClr val="FFFFFF"/>
+                </a:solidFill>
+                <a:latin typeface="Consolas"/>
+              </a:rPr>
+              <a:t>test('login con usuario bloqueado muestra mensaje de error',</a:t>
+            </a:r>
+          </a:p>
+          <a:p>
+            <a:r>
+              <a:rPr sz="1300">
+                <a:solidFill>
+                  <a:srgbClr val="FFFFFF"/>
+                </a:solidFill>
+                <a:latin typeface="Consolas"/>
+              </a:rPr>
+              <a:t>  async ({ page }) =&gt; {</a:t>
+            </a:r>
+          </a:p>
+          <a:p>
+            <a:r>
+              <a:rPr sz="1300">
+                <a:solidFill>
+                  <a:srgbClr val="FFFFFF"/>
+                </a:solidFill>
+                <a:latin typeface="Consolas"/>
+              </a:rPr>
+              <a:t>    const login = new LoginPage(page);</a:t>
+            </a:r>
+          </a:p>
+          <a:p>
+            <a:r>
+              <a:rPr sz="1300">
+                <a:solidFill>
+                  <a:srgbClr val="FFFFFF"/>
+                </a:solidFill>
+                <a:latin typeface="Consolas"/>
+              </a:rPr>
+              <a:t>    await login.abrir();</a:t>
+            </a:r>
+          </a:p>
+          <a:p>
+            <a:r>
+              <a:rPr sz="1300">
+                <a:solidFill>
+                  <a:srgbClr val="FFFFFF"/>
+                </a:solidFill>
+                <a:latin typeface="Consolas"/>
+              </a:rPr>
+              <a:t>    await login.iniciarSesion(usuarioBloqueado.nombre,</a:t>
+            </a:r>
+          </a:p>
+          <a:p>
+            <a:r>
+              <a:rPr sz="1300">
+                <a:solidFill>
+                  <a:srgbClr val="FFFFFF"/>
+                </a:solidFill>
+                <a:latin typeface="Consolas"/>
+              </a:rPr>
+              <a:t>                              usuarioBloqueado.clave);</a:t>
+            </a:r>
+          </a:p>
+          <a:p>
+            <a:r>
+              <a:rPr sz="1300">
+                <a:solidFill>
+                  <a:srgbClr val="FFFFFF"/>
+                </a:solidFill>
+                <a:latin typeface="Consolas"/>
+              </a:rPr>
+              <a:t> </a:t>
+            </a:r>
+          </a:p>
+          <a:p>
+            <a:r>
+              <a:rPr sz="1300">
+                <a:solidFill>
+                  <a:srgbClr val="FFFFFF"/>
+                </a:solidFill>
+                <a:latin typeface="Consolas"/>
+              </a:rPr>
+              <a:t>    await expect(login.mensajeError).toHaveText(</a:t>
+            </a:r>
+          </a:p>
+          <a:p>
+            <a:r>
+              <a:rPr sz="1300">
+                <a:solidFill>
+                  <a:srgbClr val="FFFFFF"/>
+                </a:solidFill>
+                <a:latin typeface="Consolas"/>
+              </a:rPr>
+              <a:t>      'Epic sadface: Sorry, this user has been locked out.');</a:t>
+            </a:r>
+          </a:p>
+          <a:p>
+            <a:r>
+              <a:rPr sz="1300">
+                <a:solidFill>
+                  <a:srgbClr val="FFFFFF"/>
+                </a:solidFill>
+                <a:latin typeface="Consolas"/>
+              </a:rPr>
+              <a:t>  });</a:t>
+            </a:r>
+          </a:p>
+        </p:txBody>
+      </p:sp>
+      <p:sp>
+        <p:nvSpPr>
+          <p:cNvPr id="7" name="TextBox 6"/>
+          <p:cNvSpPr txBox="1"/>
+          <p:nvPr/>
+        </p:nvSpPr>
+        <p:spPr>
+          <a:xfrm>
+            <a:off x="7863840" y="1737360"/>
+            <a:ext cx="3779215" cy="4389120"/>
+          </a:xfrm>
+          <a:prstGeom prst="rect">
+            <a:avLst/>
+          </a:prstGeom>
+          <a:noFill/>
+        </p:spPr>
+        <p:txBody>
+          <a:bodyPr wrap="square">
+            <a:spAutoFit/>
+          </a:bodyPr>
+          <a:lstStyle/>
+          <a:p>
+            <a:pPr>
+              <a:spcAft>
+                <a:spcPts val="1000"/>
+              </a:spcAft>
+            </a:pPr>
+            <a:r>
+              <a:rPr b="1" sz="1600">
+                <a:solidFill>
+                  <a:srgbClr val="36B5FF"/>
+                </a:solidFill>
+                <a:latin typeface="Century Gothic"/>
+              </a:rPr>
+              <a:t>▸  </a:t>
+            </a:r>
+            <a:r>
+              <a:rPr b="0" sz="1600">
+                <a:solidFill>
+                  <a:srgbClr val="36B5FF"/>
+                </a:solidFill>
+                <a:latin typeface="Consolas"/>
+              </a:rPr>
+              <a:t>page</a:t>
+            </a:r>
+            <a:r>
+              <a:rPr b="0" sz="1600">
+                <a:solidFill>
+                  <a:srgbClr val="FFFFFF"/>
+                </a:solidFill>
+                <a:latin typeface="Century Gothic"/>
+              </a:rPr>
+              <a:t>: pestaña nueva y limpia para cada prueba</a:t>
+            </a:r>
+          </a:p>
+          <a:p>
+            <a:pPr>
+              <a:spcAft>
+                <a:spcPts val="1000"/>
+              </a:spcAft>
+            </a:pPr>
+            <a:r>
+              <a:rPr b="1" sz="1600">
+                <a:solidFill>
+                  <a:srgbClr val="36B5FF"/>
+                </a:solidFill>
+                <a:latin typeface="Century Gothic"/>
+              </a:rPr>
+              <a:t>▸  </a:t>
+            </a:r>
+            <a:r>
+              <a:rPr b="0" sz="1600">
+                <a:solidFill>
+                  <a:srgbClr val="FFFFFF"/>
+                </a:solidFill>
+                <a:latin typeface="Century Gothic"/>
+              </a:rPr>
+              <a:t>Crear la página y apretar sus botones con </a:t>
+            </a:r>
+            <a:r>
+              <a:rPr b="0" sz="1600">
+                <a:solidFill>
+                  <a:srgbClr val="36B5FF"/>
+                </a:solidFill>
+                <a:latin typeface="Consolas"/>
+              </a:rPr>
+              <a:t>await</a:t>
+            </a:r>
+          </a:p>
+          <a:p>
+            <a:pPr>
+              <a:spcAft>
+                <a:spcPts val="1000"/>
+              </a:spcAft>
+            </a:pPr>
+            <a:r>
+              <a:rPr b="1" sz="1600">
+                <a:solidFill>
+                  <a:srgbClr val="36B5FF"/>
+                </a:solidFill>
+                <a:latin typeface="Century Gothic"/>
+              </a:rPr>
+              <a:t>▸  </a:t>
+            </a:r>
+            <a:r>
+              <a:rPr b="0" sz="1600">
+                <a:solidFill>
+                  <a:srgbClr val="36B5FF"/>
+                </a:solidFill>
+                <a:latin typeface="Consolas"/>
+              </a:rPr>
+              <a:t>expect(...).toHaveText(...)</a:t>
+            </a:r>
+            <a:r>
+              <a:rPr b="0" sz="1600">
+                <a:solidFill>
+                  <a:srgbClr val="FFFFFF"/>
+                </a:solidFill>
+                <a:latin typeface="Century Gothic"/>
+              </a:rPr>
+              <a:t> revisa el texto y reintenta hasta 5 s</a:t>
+            </a:r>
+          </a:p>
+        </p:txBody>
+      </p:sp>
+      <p:sp>
+        <p:nvSpPr>
+          <p:cNvPr id="8" name="TextBox 7"/>
+          <p:cNvSpPr txBox="1"/>
+          <p:nvPr/>
+        </p:nvSpPr>
+        <p:spPr>
+          <a:xfrm>
+            <a:off x="548640" y="6400800"/>
+            <a:ext cx="8229600" cy="274320"/>
           </a:xfrm>
           <a:prstGeom prst="rect">
             <a:avLst/>
@@ -6174,543 +6805,20 @@
           <a:p>
             <a:pPr algn="l"/>
             <a:r>
-              <a:rPr b="0" sz="1400">
+              <a:rPr b="0" sz="1200">
                 <a:solidFill>
                   <a:srgbClr val="C9D6E3"/>
                 </a:solidFill>
                 <a:latin typeface="Century Gothic"/>
               </a:rPr>
-              <a:t>La prueba. Dice qué hacer y qué validar.</a:t>
-            </a:r>
-          </a:p>
-        </p:txBody>
-      </p:sp>
-      <p:cxnSp>
-        <p:nvCxnSpPr>
-          <p:cNvPr id="7" name="Connector 6"/>
-          <p:cNvCxnSpPr/>
-          <p:nvPr/>
-        </p:nvCxnSpPr>
-        <p:spPr>
-          <a:xfrm>
-            <a:off x="3059353" y="3383280"/>
-            <a:ext cx="320040" cy="0"/>
-          </a:xfrm>
-          <a:prstGeom prst="line">
-            <a:avLst/>
-          </a:prstGeom>
-          <a:ln w="31750">
-            <a:solidFill>
-              <a:srgbClr val="36B5FF"/>
-            </a:solidFill>
-            <a:tailEnd type="triangle"/>
-          </a:ln>
-        </p:spPr>
-        <p:style>
-          <a:lnRef idx="2">
-            <a:schemeClr val="accent1"/>
-          </a:lnRef>
-          <a:fillRef idx="0">
-            <a:schemeClr val="accent1"/>
-          </a:fillRef>
-          <a:effectRef idx="1">
-            <a:schemeClr val="accent1"/>
-          </a:effectRef>
-          <a:fontRef idx="minor">
-            <a:schemeClr val="tx1"/>
-          </a:fontRef>
-        </p:style>
-      </p:cxnSp>
-      <p:sp>
-        <p:nvSpPr>
-          <p:cNvPr id="8" name="Rounded Rectangle 7"/>
-          <p:cNvSpPr/>
-          <p:nvPr/>
-        </p:nvSpPr>
-        <p:spPr>
-          <a:xfrm>
-            <a:off x="3425113" y="2057400"/>
-            <a:ext cx="2464993" cy="2651760"/>
-          </a:xfrm>
-          <a:prstGeom prst="roundRect">
-            <a:avLst>
-              <a:gd name="adj" fmla="val 6000"/>
-            </a:avLst>
-          </a:prstGeom>
-          <a:solidFill>
-            <a:srgbClr val="08264F"/>
-          </a:solidFill>
-          <a:ln w="15875">
-            <a:solidFill>
-              <a:srgbClr val="5EA7D8"/>
-            </a:solidFill>
-          </a:ln>
-        </p:spPr>
-        <p:style>
-          <a:lnRef idx="1">
-            <a:schemeClr val="accent1"/>
-          </a:lnRef>
-          <a:fillRef idx="3">
-            <a:schemeClr val="accent1"/>
-          </a:fillRef>
-          <a:effectRef idx="2">
-            <a:schemeClr val="accent1"/>
-          </a:effectRef>
-          <a:fontRef idx="minor">
-            <a:schemeClr val="lt1"/>
-          </a:fontRef>
-        </p:style>
-        <p:txBody>
-          <a:bodyPr rtlCol="0" anchor="ctr"/>
-          <a:lstStyle/>
-          <a:p/>
+              <a:t>Semillero QA 2026 · Clase 4 · Playwright y POM</a:t>
+            </a:r>
+          </a:p>
         </p:txBody>
       </p:sp>
       <p:sp>
         <p:nvSpPr>
           <p:cNvPr id="9" name="TextBox 8"/>
-          <p:cNvSpPr txBox="1"/>
-          <p:nvPr/>
-        </p:nvSpPr>
-        <p:spPr>
-          <a:xfrm>
-            <a:off x="3653713" y="2286000"/>
-            <a:ext cx="2007793" cy="548640"/>
-          </a:xfrm>
-          <a:prstGeom prst="rect">
-            <a:avLst/>
-          </a:prstGeom>
-          <a:noFill/>
-        </p:spPr>
-        <p:txBody>
-          <a:bodyPr wrap="square" anchor="t" lIns="0" rIns="0">
-            <a:spAutoFit/>
-          </a:bodyPr>
-          <a:lstStyle/>
-          <a:p>
-            <a:pPr algn="l"/>
-            <a:r>
-              <a:rPr b="1" sz="1800">
-                <a:solidFill>
-                  <a:srgbClr val="FFFFFF"/>
-                </a:solidFill>
-                <a:latin typeface="Century Gothic"/>
-              </a:rPr>
-              <a:t>LoginPage</a:t>
-            </a:r>
-          </a:p>
-        </p:txBody>
-      </p:sp>
-      <p:sp>
-        <p:nvSpPr>
-          <p:cNvPr id="10" name="TextBox 9"/>
-          <p:cNvSpPr txBox="1"/>
-          <p:nvPr/>
-        </p:nvSpPr>
-        <p:spPr>
-          <a:xfrm>
-            <a:off x="3653713" y="2788920"/>
-            <a:ext cx="2007793" cy="1737360"/>
-          </a:xfrm>
-          <a:prstGeom prst="rect">
-            <a:avLst/>
-          </a:prstGeom>
-          <a:noFill/>
-        </p:spPr>
-        <p:txBody>
-          <a:bodyPr wrap="square" anchor="t" lIns="0" rIns="0">
-            <a:spAutoFit/>
-          </a:bodyPr>
-          <a:lstStyle/>
-          <a:p>
-            <a:pPr algn="l"/>
-            <a:r>
-              <a:rPr b="0" sz="1400">
-                <a:solidFill>
-                  <a:srgbClr val="C9D6E3"/>
-                </a:solidFill>
-                <a:latin typeface="Century Gothic"/>
-              </a:rPr>
-              <a:t>Traduce iniciarSesion() a escribir y hacer clic.</a:t>
-            </a:r>
-          </a:p>
-        </p:txBody>
-      </p:sp>
-      <p:cxnSp>
-        <p:nvCxnSpPr>
-          <p:cNvPr id="11" name="Connector 10"/>
-          <p:cNvCxnSpPr/>
-          <p:nvPr/>
-        </p:nvCxnSpPr>
-        <p:spPr>
-          <a:xfrm>
-            <a:off x="5935826" y="3383280"/>
-            <a:ext cx="320040" cy="0"/>
-          </a:xfrm>
-          <a:prstGeom prst="line">
-            <a:avLst/>
-          </a:prstGeom>
-          <a:ln w="31750">
-            <a:solidFill>
-              <a:srgbClr val="36B5FF"/>
-            </a:solidFill>
-            <a:tailEnd type="triangle"/>
-          </a:ln>
-        </p:spPr>
-        <p:style>
-          <a:lnRef idx="2">
-            <a:schemeClr val="accent1"/>
-          </a:lnRef>
-          <a:fillRef idx="0">
-            <a:schemeClr val="accent1"/>
-          </a:fillRef>
-          <a:effectRef idx="1">
-            <a:schemeClr val="accent1"/>
-          </a:effectRef>
-          <a:fontRef idx="minor">
-            <a:schemeClr val="tx1"/>
-          </a:fontRef>
-        </p:style>
-      </p:cxnSp>
-      <p:sp>
-        <p:nvSpPr>
-          <p:cNvPr id="12" name="Rounded Rectangle 11"/>
-          <p:cNvSpPr/>
-          <p:nvPr/>
-        </p:nvSpPr>
-        <p:spPr>
-          <a:xfrm>
-            <a:off x="6301586" y="2057400"/>
-            <a:ext cx="2464993" cy="2651760"/>
-          </a:xfrm>
-          <a:prstGeom prst="roundRect">
-            <a:avLst>
-              <a:gd name="adj" fmla="val 6000"/>
-            </a:avLst>
-          </a:prstGeom>
-          <a:solidFill>
-            <a:srgbClr val="0B2C59"/>
-          </a:solidFill>
-          <a:ln w="15875">
-            <a:solidFill>
-              <a:srgbClr val="5EA7D8"/>
-            </a:solidFill>
-          </a:ln>
-        </p:spPr>
-        <p:style>
-          <a:lnRef idx="1">
-            <a:schemeClr val="accent1"/>
-          </a:lnRef>
-          <a:fillRef idx="3">
-            <a:schemeClr val="accent1"/>
-          </a:fillRef>
-          <a:effectRef idx="2">
-            <a:schemeClr val="accent1"/>
-          </a:effectRef>
-          <a:fontRef idx="minor">
-            <a:schemeClr val="lt1"/>
-          </a:fontRef>
-        </p:style>
-        <p:txBody>
-          <a:bodyPr rtlCol="0" anchor="ctr"/>
-          <a:lstStyle/>
-          <a:p/>
-        </p:txBody>
-      </p:sp>
-      <p:sp>
-        <p:nvSpPr>
-          <p:cNvPr id="13" name="TextBox 12"/>
-          <p:cNvSpPr txBox="1"/>
-          <p:nvPr/>
-        </p:nvSpPr>
-        <p:spPr>
-          <a:xfrm>
-            <a:off x="6530186" y="2286000"/>
-            <a:ext cx="2007793" cy="548640"/>
-          </a:xfrm>
-          <a:prstGeom prst="rect">
-            <a:avLst/>
-          </a:prstGeom>
-          <a:noFill/>
-        </p:spPr>
-        <p:txBody>
-          <a:bodyPr wrap="square" anchor="t" lIns="0" rIns="0">
-            <a:spAutoFit/>
-          </a:bodyPr>
-          <a:lstStyle/>
-          <a:p>
-            <a:pPr algn="l"/>
-            <a:r>
-              <a:rPr b="1" sz="1800">
-                <a:solidFill>
-                  <a:srgbClr val="FFFFFF"/>
-                </a:solidFill>
-                <a:latin typeface="Century Gothic"/>
-              </a:rPr>
-              <a:t>Playwright</a:t>
-            </a:r>
-          </a:p>
-        </p:txBody>
-      </p:sp>
-      <p:sp>
-        <p:nvSpPr>
-          <p:cNvPr id="14" name="TextBox 13"/>
-          <p:cNvSpPr txBox="1"/>
-          <p:nvPr/>
-        </p:nvSpPr>
-        <p:spPr>
-          <a:xfrm>
-            <a:off x="6530186" y="2788920"/>
-            <a:ext cx="2007793" cy="1737360"/>
-          </a:xfrm>
-          <a:prstGeom prst="rect">
-            <a:avLst/>
-          </a:prstGeom>
-          <a:noFill/>
-        </p:spPr>
-        <p:txBody>
-          <a:bodyPr wrap="square" anchor="t" lIns="0" rIns="0">
-            <a:spAutoFit/>
-          </a:bodyPr>
-          <a:lstStyle/>
-          <a:p>
-            <a:pPr algn="l"/>
-            <a:r>
-              <a:rPr b="0" sz="1400">
-                <a:solidFill>
-                  <a:srgbClr val="C9D6E3"/>
-                </a:solidFill>
-                <a:latin typeface="Century Gothic"/>
-              </a:rPr>
-              <a:t>Busca el elemento, espera y actúa.</a:t>
-            </a:r>
-          </a:p>
-        </p:txBody>
-      </p:sp>
-      <p:cxnSp>
-        <p:nvCxnSpPr>
-          <p:cNvPr id="15" name="Connector 14"/>
-          <p:cNvCxnSpPr/>
-          <p:nvPr/>
-        </p:nvCxnSpPr>
-        <p:spPr>
-          <a:xfrm>
-            <a:off x="8812299" y="3383280"/>
-            <a:ext cx="320040" cy="0"/>
-          </a:xfrm>
-          <a:prstGeom prst="line">
-            <a:avLst/>
-          </a:prstGeom>
-          <a:ln w="31750">
-            <a:solidFill>
-              <a:srgbClr val="36B5FF"/>
-            </a:solidFill>
-            <a:tailEnd type="triangle"/>
-          </a:ln>
-        </p:spPr>
-        <p:style>
-          <a:lnRef idx="2">
-            <a:schemeClr val="accent1"/>
-          </a:lnRef>
-          <a:fillRef idx="0">
-            <a:schemeClr val="accent1"/>
-          </a:fillRef>
-          <a:effectRef idx="1">
-            <a:schemeClr val="accent1"/>
-          </a:effectRef>
-          <a:fontRef idx="minor">
-            <a:schemeClr val="tx1"/>
-          </a:fontRef>
-        </p:style>
-      </p:cxnSp>
-      <p:sp>
-        <p:nvSpPr>
-          <p:cNvPr id="16" name="Rounded Rectangle 15"/>
-          <p:cNvSpPr/>
-          <p:nvPr/>
-        </p:nvSpPr>
-        <p:spPr>
-          <a:xfrm>
-            <a:off x="9178059" y="2057400"/>
-            <a:ext cx="2464993" cy="2651760"/>
-          </a:xfrm>
-          <a:prstGeom prst="roundRect">
-            <a:avLst>
-              <a:gd name="adj" fmla="val 6000"/>
-            </a:avLst>
-          </a:prstGeom>
-          <a:solidFill>
-            <a:srgbClr val="08264F"/>
-          </a:solidFill>
-          <a:ln w="15875">
-            <a:solidFill>
-              <a:srgbClr val="5EA7D8"/>
-            </a:solidFill>
-          </a:ln>
-        </p:spPr>
-        <p:style>
-          <a:lnRef idx="1">
-            <a:schemeClr val="accent1"/>
-          </a:lnRef>
-          <a:fillRef idx="3">
-            <a:schemeClr val="accent1"/>
-          </a:fillRef>
-          <a:effectRef idx="2">
-            <a:schemeClr val="accent1"/>
-          </a:effectRef>
-          <a:fontRef idx="minor">
-            <a:schemeClr val="lt1"/>
-          </a:fontRef>
-        </p:style>
-        <p:txBody>
-          <a:bodyPr rtlCol="0" anchor="ctr"/>
-          <a:lstStyle/>
-          <a:p/>
-        </p:txBody>
-      </p:sp>
-      <p:sp>
-        <p:nvSpPr>
-          <p:cNvPr id="17" name="TextBox 16"/>
-          <p:cNvSpPr txBox="1"/>
-          <p:nvPr/>
-        </p:nvSpPr>
-        <p:spPr>
-          <a:xfrm>
-            <a:off x="9406659" y="2286000"/>
-            <a:ext cx="2007793" cy="548640"/>
-          </a:xfrm>
-          <a:prstGeom prst="rect">
-            <a:avLst/>
-          </a:prstGeom>
-          <a:noFill/>
-        </p:spPr>
-        <p:txBody>
-          <a:bodyPr wrap="square" anchor="t" lIns="0" rIns="0">
-            <a:spAutoFit/>
-          </a:bodyPr>
-          <a:lstStyle/>
-          <a:p>
-            <a:pPr algn="l"/>
-            <a:r>
-              <a:rPr b="1" sz="1800">
-                <a:solidFill>
-                  <a:srgbClr val="FFFFFF"/>
-                </a:solidFill>
-                <a:latin typeface="Century Gothic"/>
-              </a:rPr>
-              <a:t>Chromium</a:t>
-            </a:r>
-          </a:p>
-        </p:txBody>
-      </p:sp>
-      <p:sp>
-        <p:nvSpPr>
-          <p:cNvPr id="18" name="TextBox 17"/>
-          <p:cNvSpPr txBox="1"/>
-          <p:nvPr/>
-        </p:nvSpPr>
-        <p:spPr>
-          <a:xfrm>
-            <a:off x="9406659" y="2788920"/>
-            <a:ext cx="2007793" cy="1737360"/>
-          </a:xfrm>
-          <a:prstGeom prst="rect">
-            <a:avLst/>
-          </a:prstGeom>
-          <a:noFill/>
-        </p:spPr>
-        <p:txBody>
-          <a:bodyPr wrap="square" anchor="t" lIns="0" rIns="0">
-            <a:spAutoFit/>
-          </a:bodyPr>
-          <a:lstStyle/>
-          <a:p>
-            <a:pPr algn="l"/>
-            <a:r>
-              <a:rPr b="0" sz="1400">
-                <a:solidFill>
-                  <a:srgbClr val="C9D6E3"/>
-                </a:solidFill>
-                <a:latin typeface="Century Gothic"/>
-              </a:rPr>
-              <a:t>Abre saucedemo.com y muestra el resultado.</a:t>
-            </a:r>
-          </a:p>
-        </p:txBody>
-      </p:sp>
-      <p:sp>
-        <p:nvSpPr>
-          <p:cNvPr id="19" name="TextBox 18"/>
-          <p:cNvSpPr txBox="1"/>
-          <p:nvPr/>
-        </p:nvSpPr>
-        <p:spPr>
-          <a:xfrm>
-            <a:off x="548640" y="5029200"/>
-            <a:ext cx="11094415" cy="1097280"/>
-          </a:xfrm>
-          <a:prstGeom prst="rect">
-            <a:avLst/>
-          </a:prstGeom>
-          <a:noFill/>
-        </p:spPr>
-        <p:txBody>
-          <a:bodyPr wrap="square" anchor="t" lIns="0" rIns="0">
-            <a:spAutoFit/>
-          </a:bodyPr>
-          <a:lstStyle/>
-          <a:p>
-            <a:pPr algn="l"/>
-            <a:r>
-              <a:rPr b="0" sz="1600">
-                <a:solidFill>
-                  <a:srgbClr val="C9D6E3"/>
-                </a:solidFill>
-                <a:latin typeface="Century Gothic"/>
-              </a:rPr>
-              <a:t>BaseTest abre el navegador antes de las pruebas y lo cierra al final.</a:t>
-            </a:r>
-          </a:p>
-        </p:txBody>
-      </p:sp>
-      <p:sp>
-        <p:nvSpPr>
-          <p:cNvPr id="20" name="TextBox 19"/>
-          <p:cNvSpPr txBox="1"/>
-          <p:nvPr/>
-        </p:nvSpPr>
-        <p:spPr>
-          <a:xfrm>
-            <a:off x="548640" y="6400800"/>
-            <a:ext cx="8229600" cy="274320"/>
-          </a:xfrm>
-          <a:prstGeom prst="rect">
-            <a:avLst/>
-          </a:prstGeom>
-          <a:noFill/>
-        </p:spPr>
-        <p:txBody>
-          <a:bodyPr wrap="square" anchor="t" lIns="0" rIns="0">
-            <a:spAutoFit/>
-          </a:bodyPr>
-          <a:lstStyle/>
-          <a:p>
-            <a:pPr algn="l"/>
-            <a:r>
-              <a:rPr b="0" sz="1200">
-                <a:solidFill>
-                  <a:srgbClr val="C9D6E3"/>
-                </a:solidFill>
-                <a:latin typeface="Century Gothic"/>
-              </a:rPr>
-              <a:t>Semillero QA 2026 · Clase 4 · Playwright y POM</a:t>
-            </a:r>
-          </a:p>
-        </p:txBody>
-      </p:sp>
-      <p:sp>
-        <p:nvSpPr>
-          <p:cNvPr id="21" name="TextBox 20"/>
           <p:cNvSpPr txBox="1"/>
           <p:nvPr/>
         </p:nvSpPr>
@@ -6853,7 +6961,7 @@
                 </a:solidFill>
                 <a:latin typeface="Century Gothic"/>
               </a:rPr>
-              <a:t>Una prueba con POM</a:t>
+              <a:t>Data driven con un for</a:t>
             </a:r>
           </a:p>
         </p:txBody>
@@ -6935,7 +7043,7 @@
                 </a:solidFill>
                 <a:latin typeface="Century Gothic"/>
               </a:rPr>
-              <a:t>Java</a:t>
+              <a:t>TypeScript</a:t>
             </a:r>
           </a:p>
         </p:txBody>
@@ -6969,7 +7077,7 @@
                 </a:solidFill>
                 <a:latin typeface="Consolas"/>
               </a:rPr>
-              <a:t>@Test</a:t>
+              <a:t>// data/usuarios.ts</a:t>
             </a:r>
           </a:p>
           <a:p>
@@ -6980,7 +7088,7 @@
                 </a:solidFill>
                 <a:latin typeface="Consolas"/>
               </a:rPr>
-              <a:t>@DisplayName("Login exitoso con usuario estándar")</a:t>
+              <a:t>export const loginsInvalidos: LoginInvalido[] = [</a:t>
             </a:r>
           </a:p>
           <a:p>
@@ -6991,7 +7099,7 @@
                 </a:solidFill>
                 <a:latin typeface="Consolas"/>
               </a:rPr>
-              <a:t>void loginExitoso() {</a:t>
+              <a:t>  { descripcion: 'clave incorrecta', ... },</a:t>
             </a:r>
           </a:p>
           <a:p>
@@ -7002,7 +7110,7 @@
                 </a:solidFill>
                 <a:latin typeface="Consolas"/>
               </a:rPr>
-              <a:t>    LoginPage login = new LoginPage(pagina);</a:t>
+              <a:t>  { descripcion: 'usuario vacío', ... },</a:t>
             </a:r>
           </a:p>
           <a:p>
@@ -7013,7 +7121,7 @@
                 </a:solidFill>
                 <a:latin typeface="Consolas"/>
               </a:rPr>
-              <a:t>    login.abrir();</a:t>
+              <a:t>  { descripcion: 'clave vacía', ... },</a:t>
             </a:r>
           </a:p>
           <a:p>
@@ -7024,7 +7132,7 @@
                 </a:solidFill>
                 <a:latin typeface="Consolas"/>
               </a:rPr>
-              <a:t>    login.iniciarSesion("standard_user", "secret_sauce");</a:t>
+              <a:t>];</a:t>
             </a:r>
           </a:p>
           <a:p>
@@ -7046,7 +7154,7 @@
                 </a:solidFill>
                 <a:latin typeface="Consolas"/>
               </a:rPr>
-              <a:t>    ProductosPage productos = new ProductosPage(pagina);</a:t>
+              <a:t>// tests/login.spec.ts</a:t>
             </a:r>
           </a:p>
           <a:p>
@@ -7057,7 +7165,95 @@
                 </a:solidFill>
                 <a:latin typeface="Consolas"/>
               </a:rPr>
-              <a:t>    assertEquals("Products", productos.titulo());</a:t>
+              <a:t>for (const caso of loginsInvalidos) {</a:t>
+            </a:r>
+          </a:p>
+          <a:p>
+            <a:r>
+              <a:rPr sz="1300">
+                <a:solidFill>
+                  <a:srgbClr val="FFFFFF"/>
+                </a:solidFill>
+                <a:latin typeface="Consolas"/>
+              </a:rPr>
+              <a:t>  test(`login inválido: ${caso.descripcion}`,</a:t>
+            </a:r>
+          </a:p>
+          <a:p>
+            <a:r>
+              <a:rPr sz="1300">
+                <a:solidFill>
+                  <a:srgbClr val="FFFFFF"/>
+                </a:solidFill>
+                <a:latin typeface="Consolas"/>
+              </a:rPr>
+              <a:t>    async ({ page }) =&gt; {</a:t>
+            </a:r>
+          </a:p>
+          <a:p>
+            <a:r>
+              <a:rPr sz="1300">
+                <a:solidFill>
+                  <a:srgbClr val="FFFFFF"/>
+                </a:solidFill>
+                <a:latin typeface="Consolas"/>
+              </a:rPr>
+              <a:t>      const login = new LoginPage(page);</a:t>
+            </a:r>
+          </a:p>
+          <a:p>
+            <a:r>
+              <a:rPr sz="1300">
+                <a:solidFill>
+                  <a:srgbClr val="FFFFFF"/>
+                </a:solidFill>
+                <a:latin typeface="Consolas"/>
+              </a:rPr>
+              <a:t>      await login.abrir();</a:t>
+            </a:r>
+          </a:p>
+          <a:p>
+            <a:r>
+              <a:rPr sz="1300">
+                <a:solidFill>
+                  <a:srgbClr val="FFFFFF"/>
+                </a:solidFill>
+                <a:latin typeface="Consolas"/>
+              </a:rPr>
+              <a:t>      await login.iniciarSesion(caso.nombre, caso.clave);</a:t>
+            </a:r>
+          </a:p>
+          <a:p>
+            <a:r>
+              <a:rPr sz="1300">
+                <a:solidFill>
+                  <a:srgbClr val="FFFFFF"/>
+                </a:solidFill>
+                <a:latin typeface="Consolas"/>
+              </a:rPr>
+              <a:t>      await expect(login.mensajeError)</a:t>
+            </a:r>
+          </a:p>
+          <a:p>
+            <a:r>
+              <a:rPr sz="1300">
+                <a:solidFill>
+                  <a:srgbClr val="FFFFFF"/>
+                </a:solidFill>
+                <a:latin typeface="Consolas"/>
+              </a:rPr>
+              <a:t>        .toHaveText(caso.mensajeEsperado);</a:t>
+            </a:r>
+          </a:p>
+          <a:p>
+            <a:r>
+              <a:rPr sz="1300">
+                <a:solidFill>
+                  <a:srgbClr val="FFFFFF"/>
+                </a:solidFill>
+                <a:latin typeface="Consolas"/>
+              </a:rPr>
+              <a:t>    });</a:t>
             </a:r>
           </a:p>
           <a:p>
@@ -7112,20 +7308,11 @@
             <a:r>
               <a:rPr b="0" sz="1600">
                 <a:solidFill>
-                  <a:srgbClr val="36B5FF"/>
-                </a:solidFill>
-                <a:latin typeface="Consolas"/>
-              </a:rPr>
-              <a:t>@Test</a:t>
-            </a:r>
-            <a:r>
-              <a:rPr b="0" sz="1600">
-                <a:solidFill>
-                  <a:srgbClr val="FFFFFF"/>
-                </a:solidFill>
-                <a:latin typeface="Century Gothic"/>
-              </a:rPr>
-              <a:t> marca el método como prueba de JUnit</a:t>
+                  <a:srgbClr val="FFFFFF"/>
+                </a:solidFill>
+                <a:latin typeface="Century Gothic"/>
+              </a:rPr>
+              <a:t>Una prueba escrita, una ejecución por caso</a:t>
             </a:r>
           </a:p>
           <a:p>
@@ -7146,79 +7333,11 @@
             <a:r>
               <a:rPr b="0" sz="1600">
                 <a:solidFill>
-                  <a:srgbClr val="36B5FF"/>
-                </a:solidFill>
-                <a:latin typeface="Consolas"/>
-              </a:rPr>
-              <a:t>@DisplayName</a:t>
-            </a:r>
-            <a:r>
-              <a:rPr b="0" sz="1600">
-                <a:solidFill>
-                  <a:srgbClr val="FFFFFF"/>
-                </a:solidFill>
-                <a:latin typeface="Century Gothic"/>
-              </a:rPr>
-              <a:t>: el nombre que ves en consola</a:t>
-            </a:r>
-          </a:p>
-          <a:p>
-            <a:pPr>
-              <a:spcAft>
-                <a:spcPts val="1000"/>
-              </a:spcAft>
-            </a:pPr>
-            <a:r>
-              <a:rPr b="1" sz="1600">
-                <a:solidFill>
-                  <a:srgbClr val="36B5FF"/>
-                </a:solidFill>
-                <a:latin typeface="Century Gothic"/>
-              </a:rPr>
-              <a:t>▸  </a:t>
-            </a:r>
-            <a:r>
-              <a:rPr b="0" sz="1600">
-                <a:solidFill>
-                  <a:srgbClr val="FFFFFF"/>
-                </a:solidFill>
-                <a:latin typeface="Century Gothic"/>
-              </a:rPr>
-              <a:t>Crear la página y apretar sus botones</a:t>
-            </a:r>
-          </a:p>
-          <a:p>
-            <a:pPr>
-              <a:spcAft>
-                <a:spcPts val="1000"/>
-              </a:spcAft>
-            </a:pPr>
-            <a:r>
-              <a:rPr b="1" sz="1600">
-                <a:solidFill>
-                  <a:srgbClr val="36B5FF"/>
-                </a:solidFill>
-                <a:latin typeface="Century Gothic"/>
-              </a:rPr>
-              <a:t>▸  </a:t>
-            </a:r>
-            <a:r>
-              <a:rPr b="0" sz="1600">
-                <a:solidFill>
-                  <a:srgbClr val="36B5FF"/>
-                </a:solidFill>
-                <a:latin typeface="Consolas"/>
-              </a:rPr>
-              <a:t>assertEquals(esperado, real)</a:t>
-            </a:r>
-            <a:r>
-              <a:rPr b="0" sz="1600">
-                <a:solidFill>
-                  <a:srgbClr val="FFFFFF"/>
-                </a:solidFill>
-                <a:latin typeface="Century Gothic"/>
-              </a:rPr>
-              <a:t>: si no son iguales, la prueba falla</a:t>
+                  <a:srgbClr val="FFFFFF"/>
+                </a:solidFill>
+                <a:latin typeface="Century Gothic"/>
+              </a:rPr>
+              <a:t>Caso nuevo = un elemento más en la lista</a:t>
             </a:r>
           </a:p>
         </p:txBody>
@@ -7328,7 +7447,7 @@
         <p:spPr>
           <a:xfrm>
             <a:off x="548640" y="411480"/>
-            <a:ext cx="1243584" cy="329184"/>
+            <a:ext cx="1837944" cy="329184"/>
           </a:xfrm>
           <a:prstGeom prst="roundRect">
             <a:avLst>
@@ -7368,7 +7487,7 @@
                 </a:solidFill>
                 <a:latin typeface="Century Gothic"/>
               </a:rPr>
-              <a:t>PRUEBAS</a:t>
+              <a:t>HERRAMIENTAS</a:t>
             </a:r>
           </a:p>
         </p:txBody>
@@ -7403,7 +7522,7 @@
                 </a:solidFill>
                 <a:latin typeface="Century Gothic"/>
               </a:rPr>
-              <a:t>Data driven con @CsvSource</a:t>
+              <a:t>VS Code con la extensión de Playwright</a:t>
             </a:r>
           </a:p>
         </p:txBody>
@@ -7417,17 +7536,17 @@
         <p:spPr>
           <a:xfrm>
             <a:off x="548640" y="1737360"/>
-            <a:ext cx="6949440" cy="4389120"/>
+            <a:ext cx="2602153" cy="4389120"/>
           </a:xfrm>
           <a:prstGeom prst="roundRect">
             <a:avLst>
-              <a:gd name="adj" fmla="val 3000"/>
+              <a:gd name="adj" fmla="val 6000"/>
             </a:avLst>
           </a:prstGeom>
           <a:solidFill>
-            <a:srgbClr val="0A1B33"/>
+            <a:srgbClr val="0B2C59"/>
           </a:solidFill>
-          <a:ln w="12700">
+          <a:ln w="15875">
             <a:solidFill>
               <a:srgbClr val="5EA7D8"/>
             </a:solidFill>
@@ -7450,9 +7569,7 @@
         <p:txBody>
           <a:bodyPr rtlCol="0" anchor="ctr"/>
           <a:lstStyle/>
-          <a:p>
-            <a:pPr algn="ctr"/>
-          </a:p>
+          <a:p/>
         </p:txBody>
       </p:sp>
       <p:sp>
@@ -7463,8 +7580,8 @@
         </p:nvSpPr>
         <p:spPr>
           <a:xfrm>
-            <a:off x="777240" y="1847088"/>
-            <a:ext cx="2743200" cy="274320"/>
+            <a:off x="777240" y="1965960"/>
+            <a:ext cx="2144953" cy="548640"/>
           </a:xfrm>
           <a:prstGeom prst="rect">
             <a:avLst/>
@@ -7479,13 +7596,13 @@
           <a:p>
             <a:pPr algn="l"/>
             <a:r>
-              <a:rPr b="1" sz="1200">
-                <a:solidFill>
-                  <a:srgbClr val="36B5FF"/>
-                </a:solidFill>
-                <a:latin typeface="Century Gothic"/>
-              </a:rPr>
-              <a:t>Java</a:t>
+              <a:rPr b="1" sz="1800">
+                <a:solidFill>
+                  <a:srgbClr val="FFFFFF"/>
+                </a:solidFill>
+                <a:latin typeface="Century Gothic"/>
+              </a:rPr>
+              <a:t>Triángulo verde</a:t>
             </a:r>
           </a:p>
         </p:txBody>
@@ -7498,281 +7615,8 @@
         </p:nvSpPr>
         <p:spPr>
           <a:xfrm>
-            <a:off x="777240" y="2194560"/>
-            <a:ext cx="6492240" cy="3840480"/>
-          </a:xfrm>
-          <a:prstGeom prst="rect">
-            <a:avLst/>
-          </a:prstGeom>
-          <a:noFill/>
-        </p:spPr>
-        <p:txBody>
-          <a:bodyPr wrap="square">
-            <a:spAutoFit/>
-          </a:bodyPr>
-          <a:lstStyle/>
-          <a:p>
-            <a:r>
-              <a:rPr sz="1300">
-                <a:solidFill>
-                  <a:srgbClr val="FFFFFF"/>
-                </a:solidFill>
-                <a:latin typeface="Consolas"/>
-              </a:rPr>
-              <a:t>@ParameterizedTest</a:t>
-            </a:r>
-          </a:p>
-          <a:p>
-            <a:r>
-              <a:rPr sz="1300">
-                <a:solidFill>
-                  <a:srgbClr val="FFFFFF"/>
-                </a:solidFill>
-                <a:latin typeface="Consolas"/>
-              </a:rPr>
-              <a:t>@CsvSource({</a:t>
-            </a:r>
-          </a:p>
-          <a:p>
-            <a:r>
-              <a:rPr sz="1300">
-                <a:solidFill>
-                  <a:srgbClr val="FFFFFF"/>
-                </a:solidFill>
-                <a:latin typeface="Consolas"/>
-              </a:rPr>
-              <a:t>  "'', secret_sauce, Epic sadface: Username is required",</a:t>
-            </a:r>
-          </a:p>
-          <a:p>
-            <a:r>
-              <a:rPr sz="1300">
-                <a:solidFill>
-                  <a:srgbClr val="FFFFFF"/>
-                </a:solidFill>
-                <a:latin typeface="Consolas"/>
-              </a:rPr>
-              <a:t>  "standard_user, '', Epic sadface: Password is required"</a:t>
-            </a:r>
-          </a:p>
-          <a:p>
-            <a:r>
-              <a:rPr sz="1300">
-                <a:solidFill>
-                  <a:srgbClr val="FFFFFF"/>
-                </a:solidFill>
-                <a:latin typeface="Consolas"/>
-              </a:rPr>
-              <a:t>  // y una fila más para la clave incorrecta</a:t>
-            </a:r>
-          </a:p>
-          <a:p>
-            <a:r>
-              <a:rPr sz="1300">
-                <a:solidFill>
-                  <a:srgbClr val="FFFFFF"/>
-                </a:solidFill>
-                <a:latin typeface="Consolas"/>
-              </a:rPr>
-              <a:t>})</a:t>
-            </a:r>
-          </a:p>
-          <a:p>
-            <a:r>
-              <a:rPr sz="1300">
-                <a:solidFill>
-                  <a:srgbClr val="FFFFFF"/>
-                </a:solidFill>
-                <a:latin typeface="Consolas"/>
-              </a:rPr>
-              <a:t>void loginInvalido(String usuario, String clave,</a:t>
-            </a:r>
-          </a:p>
-          <a:p>
-            <a:r>
-              <a:rPr sz="1300">
-                <a:solidFill>
-                  <a:srgbClr val="FFFFFF"/>
-                </a:solidFill>
-                <a:latin typeface="Consolas"/>
-              </a:rPr>
-              <a:t>                   String mensajeEsperado) {</a:t>
-            </a:r>
-          </a:p>
-          <a:p>
-            <a:r>
-              <a:rPr sz="1300">
-                <a:solidFill>
-                  <a:srgbClr val="FFFFFF"/>
-                </a:solidFill>
-                <a:latin typeface="Consolas"/>
-              </a:rPr>
-              <a:t>    LoginPage login = new LoginPage(pagina);</a:t>
-            </a:r>
-          </a:p>
-          <a:p>
-            <a:r>
-              <a:rPr sz="1300">
-                <a:solidFill>
-                  <a:srgbClr val="FFFFFF"/>
-                </a:solidFill>
-                <a:latin typeface="Consolas"/>
-              </a:rPr>
-              <a:t>    login.abrir();</a:t>
-            </a:r>
-          </a:p>
-          <a:p>
-            <a:r>
-              <a:rPr sz="1300">
-                <a:solidFill>
-                  <a:srgbClr val="FFFFFF"/>
-                </a:solidFill>
-                <a:latin typeface="Consolas"/>
-              </a:rPr>
-              <a:t>    login.iniciarSesion(usuario, clave);</a:t>
-            </a:r>
-          </a:p>
-          <a:p>
-            <a:r>
-              <a:rPr sz="1300">
-                <a:solidFill>
-                  <a:srgbClr val="FFFFFF"/>
-                </a:solidFill>
-                <a:latin typeface="Consolas"/>
-              </a:rPr>
-              <a:t>    assertEquals(mensajeEsperado, login.mensajeDeError());</a:t>
-            </a:r>
-          </a:p>
-          <a:p>
-            <a:r>
-              <a:rPr sz="1300">
-                <a:solidFill>
-                  <a:srgbClr val="FFFFFF"/>
-                </a:solidFill>
-                <a:latin typeface="Consolas"/>
-              </a:rPr>
-              <a:t>}</a:t>
-            </a:r>
-          </a:p>
-        </p:txBody>
-      </p:sp>
-      <p:sp>
-        <p:nvSpPr>
-          <p:cNvPr id="7" name="TextBox 6"/>
-          <p:cNvSpPr txBox="1"/>
-          <p:nvPr/>
-        </p:nvSpPr>
-        <p:spPr>
-          <a:xfrm>
-            <a:off x="7863840" y="1737360"/>
-            <a:ext cx="3779215" cy="4389120"/>
-          </a:xfrm>
-          <a:prstGeom prst="rect">
-            <a:avLst/>
-          </a:prstGeom>
-          <a:noFill/>
-        </p:spPr>
-        <p:txBody>
-          <a:bodyPr wrap="square">
-            <a:spAutoFit/>
-          </a:bodyPr>
-          <a:lstStyle/>
-          <a:p>
-            <a:pPr>
-              <a:spcAft>
-                <a:spcPts val="1000"/>
-              </a:spcAft>
-            </a:pPr>
-            <a:r>
-              <a:rPr b="1" sz="1600">
-                <a:solidFill>
-                  <a:srgbClr val="36B5FF"/>
-                </a:solidFill>
-                <a:latin typeface="Century Gothic"/>
-              </a:rPr>
-              <a:t>▸  </a:t>
-            </a:r>
-            <a:r>
-              <a:rPr b="0" sz="1600">
-                <a:solidFill>
-                  <a:srgbClr val="FFFFFF"/>
-                </a:solidFill>
-                <a:latin typeface="Century Gothic"/>
-              </a:rPr>
-              <a:t>Una prueba escrita, una ejecución por fila</a:t>
-            </a:r>
-          </a:p>
-          <a:p>
-            <a:pPr>
-              <a:spcAft>
-                <a:spcPts val="1000"/>
-              </a:spcAft>
-            </a:pPr>
-            <a:r>
-              <a:rPr b="1" sz="1600">
-                <a:solidFill>
-                  <a:srgbClr val="36B5FF"/>
-                </a:solidFill>
-                <a:latin typeface="Century Gothic"/>
-              </a:rPr>
-              <a:t>▸  </a:t>
-            </a:r>
-            <a:r>
-              <a:rPr b="0" sz="1600">
-                <a:solidFill>
-                  <a:srgbClr val="FFFFFF"/>
-                </a:solidFill>
-                <a:latin typeface="Century Gothic"/>
-              </a:rPr>
-              <a:t>Cada fila: usuario, clave y mensaje</a:t>
-            </a:r>
-          </a:p>
-          <a:p>
-            <a:pPr>
-              <a:spcAft>
-                <a:spcPts val="1000"/>
-              </a:spcAft>
-            </a:pPr>
-            <a:r>
-              <a:rPr b="1" sz="1600">
-                <a:solidFill>
-                  <a:srgbClr val="36B5FF"/>
-                </a:solidFill>
-                <a:latin typeface="Century Gothic"/>
-              </a:rPr>
-              <a:t>▸  </a:t>
-            </a:r>
-            <a:r>
-              <a:rPr b="0" sz="1600">
-                <a:solidFill>
-                  <a:srgbClr val="36B5FF"/>
-                </a:solidFill>
-                <a:latin typeface="Consolas"/>
-              </a:rPr>
-              <a:t>''</a:t>
-            </a:r>
-            <a:r>
-              <a:rPr b="0" sz="1600">
-                <a:solidFill>
-                  <a:srgbClr val="FFFFFF"/>
-                </a:solidFill>
-                <a:latin typeface="Century Gothic"/>
-              </a:rPr>
-              <a:t> es un campo vacío</a:t>
-            </a:r>
-          </a:p>
-        </p:txBody>
-      </p:sp>
-      <p:sp>
-        <p:nvSpPr>
-          <p:cNvPr id="8" name="TextBox 7"/>
-          <p:cNvSpPr txBox="1"/>
-          <p:nvPr/>
-        </p:nvSpPr>
-        <p:spPr>
-          <a:xfrm>
-            <a:off x="548640" y="6400800"/>
-            <a:ext cx="8229600" cy="274320"/>
+            <a:off x="777240" y="2468880"/>
+            <a:ext cx="2144953" cy="3474720"/>
           </a:xfrm>
           <a:prstGeom prst="rect">
             <a:avLst/>
@@ -7787,6 +7631,386 @@
           <a:p>
             <a:pPr algn="l"/>
             <a:r>
+              <a:rPr b="0" sz="1400">
+                <a:solidFill>
+                  <a:srgbClr val="C9D6E3"/>
+                </a:solidFill>
+                <a:latin typeface="Century Gothic"/>
+              </a:rPr>
+              <a:t>Junto a cada test. Clic para correrla, clic derecho para depurarla.</a:t>
+            </a:r>
+          </a:p>
+        </p:txBody>
+      </p:sp>
+      <p:sp>
+        <p:nvSpPr>
+          <p:cNvPr id="7" name="Rounded Rectangle 6"/>
+          <p:cNvSpPr/>
+          <p:nvPr/>
+        </p:nvSpPr>
+        <p:spPr>
+          <a:xfrm>
+            <a:off x="3379393" y="1737360"/>
+            <a:ext cx="2602153" cy="4389120"/>
+          </a:xfrm>
+          <a:prstGeom prst="roundRect">
+            <a:avLst>
+              <a:gd name="adj" fmla="val 6000"/>
+            </a:avLst>
+          </a:prstGeom>
+          <a:solidFill>
+            <a:srgbClr val="08264F"/>
+          </a:solidFill>
+          <a:ln w="15875">
+            <a:solidFill>
+              <a:srgbClr val="5EA7D8"/>
+            </a:solidFill>
+          </a:ln>
+        </p:spPr>
+        <p:style>
+          <a:lnRef idx="1">
+            <a:schemeClr val="accent1"/>
+          </a:lnRef>
+          <a:fillRef idx="3">
+            <a:schemeClr val="accent1"/>
+          </a:fillRef>
+          <a:effectRef idx="2">
+            <a:schemeClr val="accent1"/>
+          </a:effectRef>
+          <a:fontRef idx="minor">
+            <a:schemeClr val="lt1"/>
+          </a:fontRef>
+        </p:style>
+        <p:txBody>
+          <a:bodyPr rtlCol="0" anchor="ctr"/>
+          <a:lstStyle/>
+          <a:p/>
+        </p:txBody>
+      </p:sp>
+      <p:sp>
+        <p:nvSpPr>
+          <p:cNvPr id="8" name="TextBox 7"/>
+          <p:cNvSpPr txBox="1"/>
+          <p:nvPr/>
+        </p:nvSpPr>
+        <p:spPr>
+          <a:xfrm>
+            <a:off x="3607993" y="1965960"/>
+            <a:ext cx="2144953" cy="548640"/>
+          </a:xfrm>
+          <a:prstGeom prst="rect">
+            <a:avLst/>
+          </a:prstGeom>
+          <a:noFill/>
+        </p:spPr>
+        <p:txBody>
+          <a:bodyPr wrap="square" anchor="t" lIns="0" rIns="0">
+            <a:spAutoFit/>
+          </a:bodyPr>
+          <a:lstStyle/>
+          <a:p>
+            <a:pPr algn="l"/>
+            <a:r>
+              <a:rPr b="1" sz="1800">
+                <a:solidFill>
+                  <a:srgbClr val="FFFFFF"/>
+                </a:solidFill>
+                <a:latin typeface="Century Gothic"/>
+              </a:rPr>
+              <a:t>Pestaña Testing</a:t>
+            </a:r>
+          </a:p>
+        </p:txBody>
+      </p:sp>
+      <p:sp>
+        <p:nvSpPr>
+          <p:cNvPr id="9" name="TextBox 8"/>
+          <p:cNvSpPr txBox="1"/>
+          <p:nvPr/>
+        </p:nvSpPr>
+        <p:spPr>
+          <a:xfrm>
+            <a:off x="3607993" y="2468880"/>
+            <a:ext cx="2144953" cy="3474720"/>
+          </a:xfrm>
+          <a:prstGeom prst="rect">
+            <a:avLst/>
+          </a:prstGeom>
+          <a:noFill/>
+        </p:spPr>
+        <p:txBody>
+          <a:bodyPr wrap="square" anchor="t" lIns="0" rIns="0">
+            <a:spAutoFit/>
+          </a:bodyPr>
+          <a:lstStyle/>
+          <a:p>
+            <a:pPr algn="l"/>
+            <a:r>
+              <a:rPr b="0" sz="1400">
+                <a:solidFill>
+                  <a:srgbClr val="C9D6E3"/>
+                </a:solidFill>
+                <a:latin typeface="Century Gothic"/>
+              </a:rPr>
+              <a:t>Todas las pruebas en árbol: todas, un archivo o una sola.</a:t>
+            </a:r>
+          </a:p>
+        </p:txBody>
+      </p:sp>
+      <p:sp>
+        <p:nvSpPr>
+          <p:cNvPr id="10" name="Rounded Rectangle 9"/>
+          <p:cNvSpPr/>
+          <p:nvPr/>
+        </p:nvSpPr>
+        <p:spPr>
+          <a:xfrm>
+            <a:off x="6210146" y="1737360"/>
+            <a:ext cx="2602153" cy="4389120"/>
+          </a:xfrm>
+          <a:prstGeom prst="roundRect">
+            <a:avLst>
+              <a:gd name="adj" fmla="val 6000"/>
+            </a:avLst>
+          </a:prstGeom>
+          <a:solidFill>
+            <a:srgbClr val="0B2C59"/>
+          </a:solidFill>
+          <a:ln w="15875">
+            <a:solidFill>
+              <a:srgbClr val="5EA7D8"/>
+            </a:solidFill>
+          </a:ln>
+        </p:spPr>
+        <p:style>
+          <a:lnRef idx="1">
+            <a:schemeClr val="accent1"/>
+          </a:lnRef>
+          <a:fillRef idx="3">
+            <a:schemeClr val="accent1"/>
+          </a:fillRef>
+          <a:effectRef idx="2">
+            <a:schemeClr val="accent1"/>
+          </a:effectRef>
+          <a:fontRef idx="minor">
+            <a:schemeClr val="lt1"/>
+          </a:fontRef>
+        </p:style>
+        <p:txBody>
+          <a:bodyPr rtlCol="0" anchor="ctr"/>
+          <a:lstStyle/>
+          <a:p/>
+        </p:txBody>
+      </p:sp>
+      <p:sp>
+        <p:nvSpPr>
+          <p:cNvPr id="11" name="TextBox 10"/>
+          <p:cNvSpPr txBox="1"/>
+          <p:nvPr/>
+        </p:nvSpPr>
+        <p:spPr>
+          <a:xfrm>
+            <a:off x="6438746" y="1965960"/>
+            <a:ext cx="2144953" cy="548640"/>
+          </a:xfrm>
+          <a:prstGeom prst="rect">
+            <a:avLst/>
+          </a:prstGeom>
+          <a:noFill/>
+        </p:spPr>
+        <p:txBody>
+          <a:bodyPr wrap="square" anchor="t" lIns="0" rIns="0">
+            <a:spAutoFit/>
+          </a:bodyPr>
+          <a:lstStyle/>
+          <a:p>
+            <a:pPr algn="l"/>
+            <a:r>
+              <a:rPr b="1" sz="1800">
+                <a:solidFill>
+                  <a:srgbClr val="FFFFFF"/>
+                </a:solidFill>
+                <a:latin typeface="Century Gothic"/>
+              </a:rPr>
+              <a:t>Show browser</a:t>
+            </a:r>
+          </a:p>
+        </p:txBody>
+      </p:sp>
+      <p:sp>
+        <p:nvSpPr>
+          <p:cNvPr id="12" name="TextBox 11"/>
+          <p:cNvSpPr txBox="1"/>
+          <p:nvPr/>
+        </p:nvSpPr>
+        <p:spPr>
+          <a:xfrm>
+            <a:off x="6438746" y="2468880"/>
+            <a:ext cx="2144953" cy="3474720"/>
+          </a:xfrm>
+          <a:prstGeom prst="rect">
+            <a:avLst/>
+          </a:prstGeom>
+          <a:noFill/>
+        </p:spPr>
+        <p:txBody>
+          <a:bodyPr wrap="square" anchor="t" lIns="0" rIns="0">
+            <a:spAutoFit/>
+          </a:bodyPr>
+          <a:lstStyle/>
+          <a:p>
+            <a:pPr algn="l"/>
+            <a:r>
+              <a:rPr b="0" sz="1400">
+                <a:solidFill>
+                  <a:srgbClr val="C9D6E3"/>
+                </a:solidFill>
+                <a:latin typeface="Century Gothic"/>
+              </a:rPr>
+              <a:t>Muestra el navegador mientras corre la prueba.</a:t>
+            </a:r>
+          </a:p>
+        </p:txBody>
+      </p:sp>
+      <p:sp>
+        <p:nvSpPr>
+          <p:cNvPr id="13" name="Rounded Rectangle 12"/>
+          <p:cNvSpPr/>
+          <p:nvPr/>
+        </p:nvSpPr>
+        <p:spPr>
+          <a:xfrm>
+            <a:off x="9040899" y="1737360"/>
+            <a:ext cx="2602153" cy="4389120"/>
+          </a:xfrm>
+          <a:prstGeom prst="roundRect">
+            <a:avLst>
+              <a:gd name="adj" fmla="val 6000"/>
+            </a:avLst>
+          </a:prstGeom>
+          <a:solidFill>
+            <a:srgbClr val="08264F"/>
+          </a:solidFill>
+          <a:ln w="15875">
+            <a:solidFill>
+              <a:srgbClr val="5EA7D8"/>
+            </a:solidFill>
+          </a:ln>
+        </p:spPr>
+        <p:style>
+          <a:lnRef idx="1">
+            <a:schemeClr val="accent1"/>
+          </a:lnRef>
+          <a:fillRef idx="3">
+            <a:schemeClr val="accent1"/>
+          </a:fillRef>
+          <a:effectRef idx="2">
+            <a:schemeClr val="accent1"/>
+          </a:effectRef>
+          <a:fontRef idx="minor">
+            <a:schemeClr val="lt1"/>
+          </a:fontRef>
+        </p:style>
+        <p:txBody>
+          <a:bodyPr rtlCol="0" anchor="ctr"/>
+          <a:lstStyle/>
+          <a:p/>
+        </p:txBody>
+      </p:sp>
+      <p:sp>
+        <p:nvSpPr>
+          <p:cNvPr id="14" name="TextBox 13"/>
+          <p:cNvSpPr txBox="1"/>
+          <p:nvPr/>
+        </p:nvSpPr>
+        <p:spPr>
+          <a:xfrm>
+            <a:off x="9269499" y="1965960"/>
+            <a:ext cx="2144953" cy="548640"/>
+          </a:xfrm>
+          <a:prstGeom prst="rect">
+            <a:avLst/>
+          </a:prstGeom>
+          <a:noFill/>
+        </p:spPr>
+        <p:txBody>
+          <a:bodyPr wrap="square" anchor="t" lIns="0" rIns="0">
+            <a:spAutoFit/>
+          </a:bodyPr>
+          <a:lstStyle/>
+          <a:p>
+            <a:pPr algn="l"/>
+            <a:r>
+              <a:rPr b="1" sz="1800">
+                <a:solidFill>
+                  <a:srgbClr val="FFFFFF"/>
+                </a:solidFill>
+                <a:latin typeface="Century Gothic"/>
+              </a:rPr>
+              <a:t>Pick locator</a:t>
+            </a:r>
+          </a:p>
+        </p:txBody>
+      </p:sp>
+      <p:sp>
+        <p:nvSpPr>
+          <p:cNvPr id="15" name="TextBox 14"/>
+          <p:cNvSpPr txBox="1"/>
+          <p:nvPr/>
+        </p:nvSpPr>
+        <p:spPr>
+          <a:xfrm>
+            <a:off x="9269499" y="2468880"/>
+            <a:ext cx="2144953" cy="3474720"/>
+          </a:xfrm>
+          <a:prstGeom prst="rect">
+            <a:avLst/>
+          </a:prstGeom>
+          <a:noFill/>
+        </p:spPr>
+        <p:txBody>
+          <a:bodyPr wrap="square" anchor="t" lIns="0" rIns="0">
+            <a:spAutoFit/>
+          </a:bodyPr>
+          <a:lstStyle/>
+          <a:p>
+            <a:pPr algn="l"/>
+            <a:r>
+              <a:rPr b="0" sz="1400">
+                <a:solidFill>
+                  <a:srgbClr val="C9D6E3"/>
+                </a:solidFill>
+                <a:latin typeface="Century Gothic"/>
+              </a:rPr>
+              <a:t>Pasas el mouse sobre la página y te propone el localizador.</a:t>
+            </a:r>
+          </a:p>
+        </p:txBody>
+      </p:sp>
+      <p:sp>
+        <p:nvSpPr>
+          <p:cNvPr id="16" name="TextBox 15"/>
+          <p:cNvSpPr txBox="1"/>
+          <p:nvPr/>
+        </p:nvSpPr>
+        <p:spPr>
+          <a:xfrm>
+            <a:off x="548640" y="6400800"/>
+            <a:ext cx="8229600" cy="274320"/>
+          </a:xfrm>
+          <a:prstGeom prst="rect">
+            <a:avLst/>
+          </a:prstGeom>
+          <a:noFill/>
+        </p:spPr>
+        <p:txBody>
+          <a:bodyPr wrap="square" anchor="t" lIns="0" rIns="0">
+            <a:spAutoFit/>
+          </a:bodyPr>
+          <a:lstStyle/>
+          <a:p>
+            <a:pPr algn="l"/>
+            <a:r>
               <a:rPr b="0" sz="1200">
                 <a:solidFill>
                   <a:srgbClr val="C9D6E3"/>
@@ -7800,7 +8024,7 @@
       </p:sp>
       <p:sp>
         <p:nvSpPr>
-          <p:cNvPr id="9" name="TextBox 8"/>
+          <p:cNvPr id="17" name="TextBox 16"/>
           <p:cNvSpPr txBox="1"/>
           <p:nvPr/>
         </p:nvSpPr>
@@ -8154,7 +8378,7 @@
                           </a:solidFill>
                           <a:latin typeface="Century Gothic"/>
                         </a:rPr>
-                        <a:t>Privados dentro de cada página</a:t>
+                        <a:t>Dentro de cada página</a:t>
                       </a:r>
                     </a:p>
                   </a:txBody>
@@ -8222,7 +8446,7 @@
                           </a:solidFill>
                           <a:latin typeface="Century Gothic"/>
                         </a:rPr>
-                        <a:t>La página devuelve un texto y la prueba usa assertEquals</a:t>
+                        <a:t>La prueba revisa un localizador de la página con expect</a:t>
                       </a:r>
                     </a:p>
                   </a:txBody>

</xml_diff>

<commit_message>
Clase 4: usar los nombres reales de la rama 02 al comparar con Screenplay
Co-Authored-By: Claude Opus 5 (1M context) <noreply@anthropic.com>
Claude-Session: https://claude.ai/code/session_01L2JuF1iG72koPJkmuRWSzm
</commit_message>
<xml_diff>
--- a/material-de-apoyo/Clase4_Presentacion_Playwright_POM.pptx
+++ b/material-de-apoyo/Clase4_Presentacion_Playwright_POM.pptx
@@ -8288,7 +8288,7 @@
                           </a:solidFill>
                           <a:latin typeface="Century Gothic"/>
                         </a:rPr>
-                        <a:t>Un actor que ejecuta tareas (Task)</a:t>
+                        <a:t>Un actor que ejecuta tareas (tasks/IniciarSesion)</a:t>
                       </a:r>
                     </a:p>
                   </a:txBody>
@@ -8356,7 +8356,7 @@
                           </a:solidFill>
                           <a:latin typeface="Century Gothic"/>
                         </a:rPr>
-                        <a:t>En las clases de userinterfaces</a:t>
+                        <a:t>En userinterfaces/PaginaLogin</a:t>
                       </a:r>
                     </a:p>
                   </a:txBody>
@@ -8424,7 +8424,7 @@
                           </a:solidFill>
                           <a:latin typeface="Century Gothic"/>
                         </a:rPr>
-                        <a:t>Con preguntas (Question)</a:t>
+                        <a:t>Con preguntas (questions/MensajeDeError)</a:t>
                       </a:r>
                     </a:p>
                   </a:txBody>

</xml_diff>